<commit_message>
Rename appendix to Open Decisions; label each option slide
Divider reads 'Not presented · for review / Open Decisions'. Option slides
carry OPEN DECISIONS · DOOR RATE / BEST TECHS · OPTION A-E eyebrows.

Co-Authored-By: Claude Opus 5.5 <noreply@anthropic.com>
Claude-Session: https://claude.ai/code/session_01Xa4nFVxuQGXmHARGph9WhS
</commit_message>
<xml_diff>
--- a/day2-deck/decks/Day 2 Opening - Day 1 Style.pptx
+++ b/day2-deck/decks/Day 2 Opening - Day 1 Style.pptx
@@ -688,7 +688,7 @@
           <a:p>
             <a:r>
               <a:rPr lang="en-US" dirty="0"/>
-              <a:t>Appendix for review with Tommy. Alternate designs still to choose between: Door Rate / ELR % of Door Rate options, and Your Best Techs Prove It options A-C. Delete whichever we don't pick.</a:t>
+              <a:t>For review with Tommy, not for the room. Alternate versions of slides already in the deck, and slides not yet decided on. Door Rate / CP ELR % of Door Rate options A-E, and Your Best Techs Prove It options A-C. Pick one of each (or none), then delete this section before the meeting.</a:t>
             </a:r>
             <a:endParaRPr lang="en-US" dirty="0"/>
           </a:p>
@@ -2660,7 +2660,7 @@
                 <a:ea typeface="Inter" pitchFamily="34" charset="-122"/>
                 <a:cs typeface="Inter" pitchFamily="34" charset="-120"/>
               </a:rPr>
-              <a:t>APPENDIX</a:t>
+              <a:t>NOT PRESENTED · FOR REVIEW</a:t>
             </a:r>
             <a:endParaRPr lang="en-US" sz="2000" dirty="0"/>
           </a:p>
@@ -2699,7 +2699,7 @@
                 <a:ea typeface="Inter" pitchFamily="34" charset="-122"/>
                 <a:cs typeface="Inter" pitchFamily="34" charset="-120"/>
               </a:rPr>
-              <a:t>Design Options</a:t>
+              <a:t>Open Decisions</a:t>
             </a:r>
             <a:endParaRPr lang="en-US" sz="7600" dirty="0"/>
           </a:p>
@@ -2738,7 +2738,7 @@
                 <a:ea typeface="Inter" pitchFamily="34" charset="-122"/>
                 <a:cs typeface="Inter" pitchFamily="34" charset="-120"/>
               </a:rPr>
-              <a:t>Door rate   ·   Your best techs prove it</a:t>
+              <a:t>Door rate: options A–E   ·   Your best techs prove it: options A–C</a:t>
             </a:r>
             <a:endParaRPr lang="en-US" sz="2200" dirty="0"/>
           </a:p>

</xml_diff>

<commit_message>
Open Decisions: add every built slide not in the meeting flow (206 slides)
Gross Trend options, Store Records, Internal GP %, CP vs Internal GP %,
Headcount trend, Who's Moving Now alternates and Most Improved v1 join
the door rate and Best Techs options, each with an OPEN DECISIONS eyebrow.
Review decks rebuilt on the current engine.

Co-Authored-By: Claude Opus 5.5 <noreply@anthropic.com>
Claude-Session: https://claude.ai/code/session_01Xa4nFVxuQGXmHARGph9WhS
</commit_message>
<xml_diff>
--- a/day2-deck/decks/Day 2 Opening - Day 1 Style.pptx
+++ b/day2-deck/decks/Day 2 Opening - Day 1 Style.pptx
@@ -688,7 +688,7 @@
           <a:p>
             <a:r>
               <a:rPr lang="en-US" dirty="0"/>
-              <a:t>For review with Tommy, not for the room. Alternate versions of slides already in the deck, and slides not yet decided on. Door Rate / CP ELR % of Door Rate options A-E, and Your Best Techs Prove It options A-C. Pick one of each (or none), then delete this section before the meeting.</a:t>
+              <a:t>For review with Tommy, not for the room. Every slide built but not placed in the deck: alternate versions of slides already in it, and slides not yet decided on. In deck order: Gross Trend options A / B / B+Q4, Store Records (six designs), Door Rate options A-E, Internal GP %, CP vs Internal GP % options A-B, Headcount trend, Best Techs options A-C, Who's Moving Now alternate versions, Most Improved v1. Pick what moves into the deck, then delete this section before the meeting.</a:t>
             </a:r>
             <a:endParaRPr lang="en-US" dirty="0"/>
           </a:p>
@@ -2738,7 +2738,7 @@
                 <a:ea typeface="Inter" pitchFamily="34" charset="-122"/>
                 <a:cs typeface="Inter" pitchFamily="34" charset="-120"/>
               </a:rPr>
-              <a:t>Door rate: options A–E   ·   Your best techs prove it: options A–C</a:t>
+              <a:t>Gross &amp; records   ·   Door rate   ·   Internal GP %   ·   Best techs   ·   Most improved</a:t>
             </a:r>
             <a:endParaRPr lang="en-US" sz="2200" dirty="0"/>
           </a:p>

</xml_diff>

<commit_message>
Warranty Rate Increases slide from the vendor YTD RWR report; tie into warranty section
- $3,788,100 secured at 19 stores (labor $1,661,368, parts $2,126,832), store ranker
- Warranty Compliance talking point leads with it; audit takeaway compares the $400K+ debited
- Section 06 order: compliance, rate increases, warranty ELR, debits, keep the claim paid, ROs, internal

Co-Authored-By: Claude Opus 5.5 <noreply@anthropic.com>
Claude-Session: https://claude.ai/code/session_01Xa4nFVxuQGXmHARGph9WhS
</commit_message>
<xml_diff>
--- a/day2-deck/decks/Day 2 Opening - Day 1 Style.pptx
+++ b/day2-deck/decks/Day 2 Opening - Day 1 Style.pptx
@@ -3810,7 +3810,7 @@
                 <a:ea typeface="Inter" pitchFamily="34" charset="-122"/>
                 <a:cs typeface="Inter" pitchFamily="34" charset="-120"/>
               </a:rPr>
-              <a:t>Warranty audits and compliance, warranty rate and ROs, internal rate.</a:t>
+              <a:t>Warranty rate increases, audits and compliance, internal rate.</a:t>
             </a:r>
             <a:endParaRPr lang="en-US" sz="1400" dirty="0"/>
           </a:p>
@@ -7522,7 +7522,7 @@
                 <a:ea typeface="Inter" pitchFamily="34" charset="-122"/>
                 <a:cs typeface="Inter" pitchFamily="34" charset="-120"/>
               </a:rPr>
-              <a:t>Warranty audits   ·   Warranty ELR   ·   Warranty ROs   ·   Internal ELR</a:t>
+              <a:t>Rate increases   ·   Warranty audits   ·   Warranty ELR   ·   Internal ELR</a:t>
             </a:r>
             <a:endParaRPr lang="en-US" sz="2200" dirty="0"/>
           </a:p>

</xml_diff>

<commit_message>
Move internal labor and parts GP % into section 06 after internal ELR
Co-Authored-By: Claude Opus 5.5 <noreply@anthropic.com>
Claude-Session: https://claude.ai/code/session_01Xa4nFVxuQGXmHARGph9WhS
</commit_message>
<xml_diff>
--- a/day2-deck/decks/Day 2 Opening - Day 1 Style.pptx
+++ b/day2-deck/decks/Day 2 Opening - Day 1 Style.pptx
@@ -688,7 +688,7 @@
           <a:p>
             <a:r>
               <a:rPr lang="en-US" dirty="0"/>
-              <a:t>For review with Tommy, not for the room. Every slide built but not placed in the deck: alternate versions of slides already in it, and slides not yet decided on. In deck order: Gross Trend options A / B / B+Q4, Store Records (six designs), Door Rate options A-E, Internal GP %, CP vs Internal GP % options A-B, Headcount trend, Best Techs option C, Who's Moving Now alternate versions, Most Improved v1. Pick what moves into the deck, then delete this section before the meeting.</a:t>
+              <a:t>For review with Tommy, not for the room. Every slide built but not placed in the deck: alternate versions of slides already in it, and slides not yet decided on. In deck order: Gross Trend options A / B / B+Q4, Store Records (six designs), Door Rate options A-B, CP vs Internal GP % options A-B, Headcount trend, Best Techs option C, Who's Moving Now alternate versions, Most Improved v1. Pick what moves into the deck, then delete this section before the meeting.</a:t>
             </a:r>
             <a:endParaRPr lang="en-US" dirty="0"/>
           </a:p>
@@ -2738,7 +2738,7 @@
                 <a:ea typeface="Inter" pitchFamily="34" charset="-122"/>
                 <a:cs typeface="Inter" pitchFamily="34" charset="-120"/>
               </a:rPr>
-              <a:t>Gross &amp; records   ·   Door rate   ·   Internal GP %   ·   Best techs   ·   Most improved</a:t>
+              <a:t>Gross &amp; records   ·   Door rate   ·   CP vs internal   ·   Best techs   ·   Most improved</a:t>
             </a:r>
             <a:endParaRPr lang="en-US" sz="2200" dirty="0"/>
           </a:p>
@@ -3810,7 +3810,7 @@
                 <a:ea typeface="Inter" pitchFamily="34" charset="-122"/>
                 <a:cs typeface="Inter" pitchFamily="34" charset="-120"/>
               </a:rPr>
-              <a:t>Warranty rate increases, audits and compliance, internal rate.</a:t>
+              <a:t>Warranty rate increases, audits and compliance, internal rate and margin.</a:t>
             </a:r>
             <a:endParaRPr lang="en-US" sz="1400" dirty="0"/>
           </a:p>

</xml_diff>

<commit_message>
Internal ELR and internal GP % move to Labor Mix; section 06 becomes Warranty
Co-Authored-By: Claude Opus 5.5 <noreply@anthropic.com>
Claude-Session: https://claude.ai/code/session_01Xa4nFVxuQGXmHARGph9WhS
</commit_message>
<xml_diff>
--- a/day2-deck/decks/Day 2 Opening - Day 1 Style.pptx
+++ b/day2-deck/decks/Day 2 Opening - Day 1 Style.pptx
@@ -2144,7 +2144,7 @@
               <a:buNone/>
             </a:pPr>
             <a:r>
-              <a:rPr lang="en-US" sz="1550" dirty="0">
+              <a:rPr lang="en-US" sz="1700" dirty="0">
                 <a:solidFill>
                   <a:srgbClr val="595959"/>
                 </a:solidFill>
@@ -2154,7 +2154,7 @@
               </a:rPr>
               <a:t>Gross</a:t>
             </a:r>
-            <a:endParaRPr lang="en-US" sz="1550" dirty="0"/>
+            <a:endParaRPr lang="en-US" sz="1700" dirty="0"/>
           </a:p>
         </p:txBody>
       </p:sp>
@@ -2203,7 +2203,7 @@
               <a:buNone/>
             </a:pPr>
             <a:r>
-              <a:rPr lang="en-US" sz="1550" dirty="0">
+              <a:rPr lang="en-US" sz="1700" dirty="0">
                 <a:solidFill>
                   <a:srgbClr val="595959"/>
                 </a:solidFill>
@@ -2213,7 +2213,7 @@
               </a:rPr>
               <a:t>Profitability</a:t>
             </a:r>
-            <a:endParaRPr lang="en-US" sz="1550" dirty="0"/>
+            <a:endParaRPr lang="en-US" sz="1700" dirty="0"/>
           </a:p>
         </p:txBody>
       </p:sp>
@@ -2262,7 +2262,7 @@
               <a:buNone/>
             </a:pPr>
             <a:r>
-              <a:rPr lang="en-US" sz="1550" dirty="0">
+              <a:rPr lang="en-US" sz="1700" dirty="0">
                 <a:solidFill>
                   <a:srgbClr val="595959"/>
                 </a:solidFill>
@@ -2272,7 +2272,7 @@
               </a:rPr>
               <a:t>CP Engine</a:t>
             </a:r>
-            <a:endParaRPr lang="en-US" sz="1550" dirty="0"/>
+            <a:endParaRPr lang="en-US" sz="1700" dirty="0"/>
           </a:p>
         </p:txBody>
       </p:sp>
@@ -2321,7 +2321,7 @@
               <a:buNone/>
             </a:pPr>
             <a:r>
-              <a:rPr lang="en-US" sz="1550" dirty="0">
+              <a:rPr lang="en-US" sz="1700" dirty="0">
                 <a:solidFill>
                   <a:srgbClr val="595959"/>
                 </a:solidFill>
@@ -2331,7 +2331,7 @@
               </a:rPr>
               <a:t>Labor Mix</a:t>
             </a:r>
-            <a:endParaRPr lang="en-US" sz="1550" dirty="0"/>
+            <a:endParaRPr lang="en-US" sz="1700" dirty="0"/>
           </a:p>
         </p:txBody>
       </p:sp>
@@ -2380,7 +2380,7 @@
               <a:buNone/>
             </a:pPr>
             <a:r>
-              <a:rPr lang="en-US" sz="1550" dirty="0">
+              <a:rPr lang="en-US" sz="1700" dirty="0">
                 <a:solidFill>
                   <a:srgbClr val="595959"/>
                 </a:solidFill>
@@ -2390,7 +2390,7 @@
               </a:rPr>
               <a:t>Opcodes</a:t>
             </a:r>
-            <a:endParaRPr lang="en-US" sz="1550" dirty="0"/>
+            <a:endParaRPr lang="en-US" sz="1700" dirty="0"/>
           </a:p>
         </p:txBody>
       </p:sp>
@@ -2439,7 +2439,7 @@
               <a:buNone/>
             </a:pPr>
             <a:r>
-              <a:rPr lang="en-US" sz="1550" dirty="0">
+              <a:rPr lang="en-US" sz="1700" dirty="0">
                 <a:solidFill>
                   <a:srgbClr val="595959"/>
                 </a:solidFill>
@@ -2447,9 +2447,9 @@
                 <a:ea typeface="Inter" pitchFamily="34" charset="-122"/>
                 <a:cs typeface="Inter" pitchFamily="34" charset="-120"/>
               </a:rPr>
-              <a:t>Warranty &amp; Internal</a:t>
-            </a:r>
-            <a:endParaRPr lang="en-US" sz="1550" dirty="0"/>
+              <a:t>Warranty</a:t>
+            </a:r>
+            <a:endParaRPr lang="en-US" sz="1700" dirty="0"/>
           </a:p>
         </p:txBody>
       </p:sp>
@@ -2498,7 +2498,7 @@
               <a:buNone/>
             </a:pPr>
             <a:r>
-              <a:rPr lang="en-US" sz="1550" dirty="0">
+              <a:rPr lang="en-US" sz="1700" dirty="0">
                 <a:solidFill>
                   <a:srgbClr val="595959"/>
                 </a:solidFill>
@@ -2508,7 +2508,7 @@
               </a:rPr>
               <a:t>Productivity</a:t>
             </a:r>
-            <a:endParaRPr lang="en-US" sz="1550" dirty="0"/>
+            <a:endParaRPr lang="en-US" sz="1700" dirty="0"/>
           </a:p>
         </p:txBody>
       </p:sp>
@@ -2557,7 +2557,7 @@
               <a:buNone/>
             </a:pPr>
             <a:r>
-              <a:rPr lang="en-US" sz="1550" b="1" dirty="0">
+              <a:rPr lang="en-US" sz="1700" b="1" dirty="0">
                 <a:solidFill>
                   <a:srgbClr val="1A1A1A"/>
                 </a:solidFill>
@@ -2567,7 +2567,7 @@
               </a:rPr>
               <a:t>Close</a:t>
             </a:r>
-            <a:endParaRPr lang="en-US" sz="1550" dirty="0"/>
+            <a:endParaRPr lang="en-US" sz="1700" dirty="0"/>
           </a:p>
         </p:txBody>
       </p:sp>
@@ -3496,7 +3496,7 @@
                 <a:ea typeface="Inter" pitchFamily="34" charset="-122"/>
                 <a:cs typeface="Inter" pitchFamily="34" charset="-120"/>
               </a:rPr>
-              <a:t>Express, maintenance and repair mix.</a:t>
+              <a:t>Pay type and internal, maintenance and repair mix.</a:t>
             </a:r>
             <a:endParaRPr lang="en-US" sz="1400" dirty="0"/>
           </a:p>
@@ -3771,7 +3771,7 @@
                 <a:ea typeface="Inter" pitchFamily="34" charset="-122"/>
                 <a:cs typeface="Inter" pitchFamily="34" charset="-120"/>
               </a:rPr>
-              <a:t>Warranty &amp; Internal</a:t>
+              <a:t>Warranty</a:t>
             </a:r>
             <a:endParaRPr lang="en-US" sz="1700" dirty="0"/>
           </a:p>
@@ -3810,7 +3810,7 @@
                 <a:ea typeface="Inter" pitchFamily="34" charset="-122"/>
                 <a:cs typeface="Inter" pitchFamily="34" charset="-120"/>
               </a:rPr>
-              <a:t>Warranty rate increases, audits and compliance, internal rate and margin.</a:t>
+              <a:t>Rate increases, warranty rate and parts margin, audits and compliance.</a:t>
             </a:r>
             <a:endParaRPr lang="en-US" sz="1400" dirty="0"/>
           </a:p>
@@ -4348,7 +4348,7 @@
               <a:buNone/>
             </a:pPr>
             <a:r>
-              <a:rPr lang="en-US" sz="1550" b="1" dirty="0">
+              <a:rPr lang="en-US" sz="1700" b="1" dirty="0">
                 <a:solidFill>
                   <a:srgbClr val="1A1A1A"/>
                 </a:solidFill>
@@ -4358,7 +4358,7 @@
               </a:rPr>
               <a:t>Gross</a:t>
             </a:r>
-            <a:endParaRPr lang="en-US" sz="1550" dirty="0"/>
+            <a:endParaRPr lang="en-US" sz="1700" dirty="0"/>
           </a:p>
         </p:txBody>
       </p:sp>
@@ -4407,7 +4407,7 @@
               <a:buNone/>
             </a:pPr>
             <a:r>
-              <a:rPr lang="en-US" sz="1550" dirty="0">
+              <a:rPr lang="en-US" sz="1700" dirty="0">
                 <a:solidFill>
                   <a:srgbClr val="595959"/>
                 </a:solidFill>
@@ -4417,7 +4417,7 @@
               </a:rPr>
               <a:t>Profitability</a:t>
             </a:r>
-            <a:endParaRPr lang="en-US" sz="1550" dirty="0"/>
+            <a:endParaRPr lang="en-US" sz="1700" dirty="0"/>
           </a:p>
         </p:txBody>
       </p:sp>
@@ -4466,7 +4466,7 @@
               <a:buNone/>
             </a:pPr>
             <a:r>
-              <a:rPr lang="en-US" sz="1550" dirty="0">
+              <a:rPr lang="en-US" sz="1700" dirty="0">
                 <a:solidFill>
                   <a:srgbClr val="595959"/>
                 </a:solidFill>
@@ -4476,7 +4476,7 @@
               </a:rPr>
               <a:t>CP Engine</a:t>
             </a:r>
-            <a:endParaRPr lang="en-US" sz="1550" dirty="0"/>
+            <a:endParaRPr lang="en-US" sz="1700" dirty="0"/>
           </a:p>
         </p:txBody>
       </p:sp>
@@ -4525,7 +4525,7 @@
               <a:buNone/>
             </a:pPr>
             <a:r>
-              <a:rPr lang="en-US" sz="1550" dirty="0">
+              <a:rPr lang="en-US" sz="1700" dirty="0">
                 <a:solidFill>
                   <a:srgbClr val="595959"/>
                 </a:solidFill>
@@ -4535,7 +4535,7 @@
               </a:rPr>
               <a:t>Labor Mix</a:t>
             </a:r>
-            <a:endParaRPr lang="en-US" sz="1550" dirty="0"/>
+            <a:endParaRPr lang="en-US" sz="1700" dirty="0"/>
           </a:p>
         </p:txBody>
       </p:sp>
@@ -4584,7 +4584,7 @@
               <a:buNone/>
             </a:pPr>
             <a:r>
-              <a:rPr lang="en-US" sz="1550" dirty="0">
+              <a:rPr lang="en-US" sz="1700" dirty="0">
                 <a:solidFill>
                   <a:srgbClr val="595959"/>
                 </a:solidFill>
@@ -4594,7 +4594,7 @@
               </a:rPr>
               <a:t>Opcodes</a:t>
             </a:r>
-            <a:endParaRPr lang="en-US" sz="1550" dirty="0"/>
+            <a:endParaRPr lang="en-US" sz="1700" dirty="0"/>
           </a:p>
         </p:txBody>
       </p:sp>
@@ -4643,7 +4643,7 @@
               <a:buNone/>
             </a:pPr>
             <a:r>
-              <a:rPr lang="en-US" sz="1550" dirty="0">
+              <a:rPr lang="en-US" sz="1700" dirty="0">
                 <a:solidFill>
                   <a:srgbClr val="595959"/>
                 </a:solidFill>
@@ -4651,9 +4651,9 @@
                 <a:ea typeface="Inter" pitchFamily="34" charset="-122"/>
                 <a:cs typeface="Inter" pitchFamily="34" charset="-120"/>
               </a:rPr>
-              <a:t>Warranty &amp; Internal</a:t>
-            </a:r>
-            <a:endParaRPr lang="en-US" sz="1550" dirty="0"/>
+              <a:t>Warranty</a:t>
+            </a:r>
+            <a:endParaRPr lang="en-US" sz="1700" dirty="0"/>
           </a:p>
         </p:txBody>
       </p:sp>
@@ -4702,7 +4702,7 @@
               <a:buNone/>
             </a:pPr>
             <a:r>
-              <a:rPr lang="en-US" sz="1550" dirty="0">
+              <a:rPr lang="en-US" sz="1700" dirty="0">
                 <a:solidFill>
                   <a:srgbClr val="595959"/>
                 </a:solidFill>
@@ -4712,7 +4712,7 @@
               </a:rPr>
               <a:t>Productivity</a:t>
             </a:r>
-            <a:endParaRPr lang="en-US" sz="1550" dirty="0"/>
+            <a:endParaRPr lang="en-US" sz="1700" dirty="0"/>
           </a:p>
         </p:txBody>
       </p:sp>
@@ -4761,7 +4761,7 @@
               <a:buNone/>
             </a:pPr>
             <a:r>
-              <a:rPr lang="en-US" sz="1550" dirty="0">
+              <a:rPr lang="en-US" sz="1700" dirty="0">
                 <a:solidFill>
                   <a:srgbClr val="595959"/>
                 </a:solidFill>
@@ -4771,7 +4771,7 @@
               </a:rPr>
               <a:t>Close</a:t>
             </a:r>
-            <a:endParaRPr lang="en-US" sz="1550" dirty="0"/>
+            <a:endParaRPr lang="en-US" sz="1700" dirty="0"/>
           </a:p>
         </p:txBody>
       </p:sp>
@@ -4993,7 +4993,7 @@
               <a:buNone/>
             </a:pPr>
             <a:r>
-              <a:rPr lang="en-US" sz="1550" dirty="0">
+              <a:rPr lang="en-US" sz="1700" dirty="0">
                 <a:solidFill>
                   <a:srgbClr val="595959"/>
                 </a:solidFill>
@@ -5003,7 +5003,7 @@
               </a:rPr>
               <a:t>Gross</a:t>
             </a:r>
-            <a:endParaRPr lang="en-US" sz="1550" dirty="0"/>
+            <a:endParaRPr lang="en-US" sz="1700" dirty="0"/>
           </a:p>
         </p:txBody>
       </p:sp>
@@ -5052,7 +5052,7 @@
               <a:buNone/>
             </a:pPr>
             <a:r>
-              <a:rPr lang="en-US" sz="1550" b="1" dirty="0">
+              <a:rPr lang="en-US" sz="1700" b="1" dirty="0">
                 <a:solidFill>
                   <a:srgbClr val="1A1A1A"/>
                 </a:solidFill>
@@ -5062,7 +5062,7 @@
               </a:rPr>
               <a:t>Profitability</a:t>
             </a:r>
-            <a:endParaRPr lang="en-US" sz="1550" dirty="0"/>
+            <a:endParaRPr lang="en-US" sz="1700" dirty="0"/>
           </a:p>
         </p:txBody>
       </p:sp>
@@ -5111,7 +5111,7 @@
               <a:buNone/>
             </a:pPr>
             <a:r>
-              <a:rPr lang="en-US" sz="1550" dirty="0">
+              <a:rPr lang="en-US" sz="1700" dirty="0">
                 <a:solidFill>
                   <a:srgbClr val="595959"/>
                 </a:solidFill>
@@ -5121,7 +5121,7 @@
               </a:rPr>
               <a:t>CP Engine</a:t>
             </a:r>
-            <a:endParaRPr lang="en-US" sz="1550" dirty="0"/>
+            <a:endParaRPr lang="en-US" sz="1700" dirty="0"/>
           </a:p>
         </p:txBody>
       </p:sp>
@@ -5170,7 +5170,7 @@
               <a:buNone/>
             </a:pPr>
             <a:r>
-              <a:rPr lang="en-US" sz="1550" dirty="0">
+              <a:rPr lang="en-US" sz="1700" dirty="0">
                 <a:solidFill>
                   <a:srgbClr val="595959"/>
                 </a:solidFill>
@@ -5180,7 +5180,7 @@
               </a:rPr>
               <a:t>Labor Mix</a:t>
             </a:r>
-            <a:endParaRPr lang="en-US" sz="1550" dirty="0"/>
+            <a:endParaRPr lang="en-US" sz="1700" dirty="0"/>
           </a:p>
         </p:txBody>
       </p:sp>
@@ -5229,7 +5229,7 @@
               <a:buNone/>
             </a:pPr>
             <a:r>
-              <a:rPr lang="en-US" sz="1550" dirty="0">
+              <a:rPr lang="en-US" sz="1700" dirty="0">
                 <a:solidFill>
                   <a:srgbClr val="595959"/>
                 </a:solidFill>
@@ -5239,7 +5239,7 @@
               </a:rPr>
               <a:t>Opcodes</a:t>
             </a:r>
-            <a:endParaRPr lang="en-US" sz="1550" dirty="0"/>
+            <a:endParaRPr lang="en-US" sz="1700" dirty="0"/>
           </a:p>
         </p:txBody>
       </p:sp>
@@ -5288,7 +5288,7 @@
               <a:buNone/>
             </a:pPr>
             <a:r>
-              <a:rPr lang="en-US" sz="1550" dirty="0">
+              <a:rPr lang="en-US" sz="1700" dirty="0">
                 <a:solidFill>
                   <a:srgbClr val="595959"/>
                 </a:solidFill>
@@ -5296,9 +5296,9 @@
                 <a:ea typeface="Inter" pitchFamily="34" charset="-122"/>
                 <a:cs typeface="Inter" pitchFamily="34" charset="-120"/>
               </a:rPr>
-              <a:t>Warranty &amp; Internal</a:t>
-            </a:r>
-            <a:endParaRPr lang="en-US" sz="1550" dirty="0"/>
+              <a:t>Warranty</a:t>
+            </a:r>
+            <a:endParaRPr lang="en-US" sz="1700" dirty="0"/>
           </a:p>
         </p:txBody>
       </p:sp>
@@ -5347,7 +5347,7 @@
               <a:buNone/>
             </a:pPr>
             <a:r>
-              <a:rPr lang="en-US" sz="1550" dirty="0">
+              <a:rPr lang="en-US" sz="1700" dirty="0">
                 <a:solidFill>
                   <a:srgbClr val="595959"/>
                 </a:solidFill>
@@ -5357,7 +5357,7 @@
               </a:rPr>
               <a:t>Productivity</a:t>
             </a:r>
-            <a:endParaRPr lang="en-US" sz="1550" dirty="0"/>
+            <a:endParaRPr lang="en-US" sz="1700" dirty="0"/>
           </a:p>
         </p:txBody>
       </p:sp>
@@ -5406,7 +5406,7 @@
               <a:buNone/>
             </a:pPr>
             <a:r>
-              <a:rPr lang="en-US" sz="1550" dirty="0">
+              <a:rPr lang="en-US" sz="1700" dirty="0">
                 <a:solidFill>
                   <a:srgbClr val="595959"/>
                 </a:solidFill>
@@ -5416,7 +5416,7 @@
               </a:rPr>
               <a:t>Close</a:t>
             </a:r>
-            <a:endParaRPr lang="en-US" sz="1550" dirty="0"/>
+            <a:endParaRPr lang="en-US" sz="1700" dirty="0"/>
           </a:p>
         </p:txBody>
       </p:sp>
@@ -5638,7 +5638,7 @@
               <a:buNone/>
             </a:pPr>
             <a:r>
-              <a:rPr lang="en-US" sz="1550" dirty="0">
+              <a:rPr lang="en-US" sz="1700" dirty="0">
                 <a:solidFill>
                   <a:srgbClr val="595959"/>
                 </a:solidFill>
@@ -5648,7 +5648,7 @@
               </a:rPr>
               <a:t>Gross</a:t>
             </a:r>
-            <a:endParaRPr lang="en-US" sz="1550" dirty="0"/>
+            <a:endParaRPr lang="en-US" sz="1700" dirty="0"/>
           </a:p>
         </p:txBody>
       </p:sp>
@@ -5697,7 +5697,7 @@
               <a:buNone/>
             </a:pPr>
             <a:r>
-              <a:rPr lang="en-US" sz="1550" dirty="0">
+              <a:rPr lang="en-US" sz="1700" dirty="0">
                 <a:solidFill>
                   <a:srgbClr val="595959"/>
                 </a:solidFill>
@@ -5707,7 +5707,7 @@
               </a:rPr>
               <a:t>Profitability</a:t>
             </a:r>
-            <a:endParaRPr lang="en-US" sz="1550" dirty="0"/>
+            <a:endParaRPr lang="en-US" sz="1700" dirty="0"/>
           </a:p>
         </p:txBody>
       </p:sp>
@@ -5756,7 +5756,7 @@
               <a:buNone/>
             </a:pPr>
             <a:r>
-              <a:rPr lang="en-US" sz="1550" b="1" dirty="0">
+              <a:rPr lang="en-US" sz="1700" b="1" dirty="0">
                 <a:solidFill>
                   <a:srgbClr val="1A1A1A"/>
                 </a:solidFill>
@@ -5766,7 +5766,7 @@
               </a:rPr>
               <a:t>CP Engine</a:t>
             </a:r>
-            <a:endParaRPr lang="en-US" sz="1550" dirty="0"/>
+            <a:endParaRPr lang="en-US" sz="1700" dirty="0"/>
           </a:p>
         </p:txBody>
       </p:sp>
@@ -5815,7 +5815,7 @@
               <a:buNone/>
             </a:pPr>
             <a:r>
-              <a:rPr lang="en-US" sz="1550" dirty="0">
+              <a:rPr lang="en-US" sz="1700" dirty="0">
                 <a:solidFill>
                   <a:srgbClr val="595959"/>
                 </a:solidFill>
@@ -5825,7 +5825,7 @@
               </a:rPr>
               <a:t>Labor Mix</a:t>
             </a:r>
-            <a:endParaRPr lang="en-US" sz="1550" dirty="0"/>
+            <a:endParaRPr lang="en-US" sz="1700" dirty="0"/>
           </a:p>
         </p:txBody>
       </p:sp>
@@ -5874,7 +5874,7 @@
               <a:buNone/>
             </a:pPr>
             <a:r>
-              <a:rPr lang="en-US" sz="1550" dirty="0">
+              <a:rPr lang="en-US" sz="1700" dirty="0">
                 <a:solidFill>
                   <a:srgbClr val="595959"/>
                 </a:solidFill>
@@ -5884,7 +5884,7 @@
               </a:rPr>
               <a:t>Opcodes</a:t>
             </a:r>
-            <a:endParaRPr lang="en-US" sz="1550" dirty="0"/>
+            <a:endParaRPr lang="en-US" sz="1700" dirty="0"/>
           </a:p>
         </p:txBody>
       </p:sp>
@@ -5933,7 +5933,7 @@
               <a:buNone/>
             </a:pPr>
             <a:r>
-              <a:rPr lang="en-US" sz="1550" dirty="0">
+              <a:rPr lang="en-US" sz="1700" dirty="0">
                 <a:solidFill>
                   <a:srgbClr val="595959"/>
                 </a:solidFill>
@@ -5941,9 +5941,9 @@
                 <a:ea typeface="Inter" pitchFamily="34" charset="-122"/>
                 <a:cs typeface="Inter" pitchFamily="34" charset="-120"/>
               </a:rPr>
-              <a:t>Warranty &amp; Internal</a:t>
-            </a:r>
-            <a:endParaRPr lang="en-US" sz="1550" dirty="0"/>
+              <a:t>Warranty</a:t>
+            </a:r>
+            <a:endParaRPr lang="en-US" sz="1700" dirty="0"/>
           </a:p>
         </p:txBody>
       </p:sp>
@@ -5992,7 +5992,7 @@
               <a:buNone/>
             </a:pPr>
             <a:r>
-              <a:rPr lang="en-US" sz="1550" dirty="0">
+              <a:rPr lang="en-US" sz="1700" dirty="0">
                 <a:solidFill>
                   <a:srgbClr val="595959"/>
                 </a:solidFill>
@@ -6002,7 +6002,7 @@
               </a:rPr>
               <a:t>Productivity</a:t>
             </a:r>
-            <a:endParaRPr lang="en-US" sz="1550" dirty="0"/>
+            <a:endParaRPr lang="en-US" sz="1700" dirty="0"/>
           </a:p>
         </p:txBody>
       </p:sp>
@@ -6051,7 +6051,7 @@
               <a:buNone/>
             </a:pPr>
             <a:r>
-              <a:rPr lang="en-US" sz="1550" dirty="0">
+              <a:rPr lang="en-US" sz="1700" dirty="0">
                 <a:solidFill>
                   <a:srgbClr val="595959"/>
                 </a:solidFill>
@@ -6061,7 +6061,7 @@
               </a:rPr>
               <a:t>Close</a:t>
             </a:r>
-            <a:endParaRPr lang="en-US" sz="1550" dirty="0"/>
+            <a:endParaRPr lang="en-US" sz="1700" dirty="0"/>
           </a:p>
         </p:txBody>
       </p:sp>
@@ -6232,7 +6232,7 @@
                 <a:ea typeface="Inter" pitchFamily="34" charset="-122"/>
                 <a:cs typeface="Inter" pitchFamily="34" charset="-120"/>
               </a:rPr>
-              <a:t>Pay type   ·   Work type   ·   Op code descriptions</a:t>
+              <a:t>Pay type   ·   Internal rate &amp; margin   ·   Work type   ·   Op code descriptions</a:t>
             </a:r>
             <a:endParaRPr lang="en-US" sz="2200" dirty="0"/>
           </a:p>
@@ -6283,7 +6283,7 @@
               <a:buNone/>
             </a:pPr>
             <a:r>
-              <a:rPr lang="en-US" sz="1550" dirty="0">
+              <a:rPr lang="en-US" sz="1700" dirty="0">
                 <a:solidFill>
                   <a:srgbClr val="595959"/>
                 </a:solidFill>
@@ -6293,7 +6293,7 @@
               </a:rPr>
               <a:t>Gross</a:t>
             </a:r>
-            <a:endParaRPr lang="en-US" sz="1550" dirty="0"/>
+            <a:endParaRPr lang="en-US" sz="1700" dirty="0"/>
           </a:p>
         </p:txBody>
       </p:sp>
@@ -6342,7 +6342,7 @@
               <a:buNone/>
             </a:pPr>
             <a:r>
-              <a:rPr lang="en-US" sz="1550" dirty="0">
+              <a:rPr lang="en-US" sz="1700" dirty="0">
                 <a:solidFill>
                   <a:srgbClr val="595959"/>
                 </a:solidFill>
@@ -6352,7 +6352,7 @@
               </a:rPr>
               <a:t>Profitability</a:t>
             </a:r>
-            <a:endParaRPr lang="en-US" sz="1550" dirty="0"/>
+            <a:endParaRPr lang="en-US" sz="1700" dirty="0"/>
           </a:p>
         </p:txBody>
       </p:sp>
@@ -6401,7 +6401,7 @@
               <a:buNone/>
             </a:pPr>
             <a:r>
-              <a:rPr lang="en-US" sz="1550" dirty="0">
+              <a:rPr lang="en-US" sz="1700" dirty="0">
                 <a:solidFill>
                   <a:srgbClr val="595959"/>
                 </a:solidFill>
@@ -6411,7 +6411,7 @@
               </a:rPr>
               <a:t>CP Engine</a:t>
             </a:r>
-            <a:endParaRPr lang="en-US" sz="1550" dirty="0"/>
+            <a:endParaRPr lang="en-US" sz="1700" dirty="0"/>
           </a:p>
         </p:txBody>
       </p:sp>
@@ -6460,7 +6460,7 @@
               <a:buNone/>
             </a:pPr>
             <a:r>
-              <a:rPr lang="en-US" sz="1550" b="1" dirty="0">
+              <a:rPr lang="en-US" sz="1700" b="1" dirty="0">
                 <a:solidFill>
                   <a:srgbClr val="1A1A1A"/>
                 </a:solidFill>
@@ -6470,7 +6470,7 @@
               </a:rPr>
               <a:t>Labor Mix</a:t>
             </a:r>
-            <a:endParaRPr lang="en-US" sz="1550" dirty="0"/>
+            <a:endParaRPr lang="en-US" sz="1700" dirty="0"/>
           </a:p>
         </p:txBody>
       </p:sp>
@@ -6519,7 +6519,7 @@
               <a:buNone/>
             </a:pPr>
             <a:r>
-              <a:rPr lang="en-US" sz="1550" dirty="0">
+              <a:rPr lang="en-US" sz="1700" dirty="0">
                 <a:solidFill>
                   <a:srgbClr val="595959"/>
                 </a:solidFill>
@@ -6529,7 +6529,7 @@
               </a:rPr>
               <a:t>Opcodes</a:t>
             </a:r>
-            <a:endParaRPr lang="en-US" sz="1550" dirty="0"/>
+            <a:endParaRPr lang="en-US" sz="1700" dirty="0"/>
           </a:p>
         </p:txBody>
       </p:sp>
@@ -6578,7 +6578,7 @@
               <a:buNone/>
             </a:pPr>
             <a:r>
-              <a:rPr lang="en-US" sz="1550" dirty="0">
+              <a:rPr lang="en-US" sz="1700" dirty="0">
                 <a:solidFill>
                   <a:srgbClr val="595959"/>
                 </a:solidFill>
@@ -6586,9 +6586,9 @@
                 <a:ea typeface="Inter" pitchFamily="34" charset="-122"/>
                 <a:cs typeface="Inter" pitchFamily="34" charset="-120"/>
               </a:rPr>
-              <a:t>Warranty &amp; Internal</a:t>
-            </a:r>
-            <a:endParaRPr lang="en-US" sz="1550" dirty="0"/>
+              <a:t>Warranty</a:t>
+            </a:r>
+            <a:endParaRPr lang="en-US" sz="1700" dirty="0"/>
           </a:p>
         </p:txBody>
       </p:sp>
@@ -6637,7 +6637,7 @@
               <a:buNone/>
             </a:pPr>
             <a:r>
-              <a:rPr lang="en-US" sz="1550" dirty="0">
+              <a:rPr lang="en-US" sz="1700" dirty="0">
                 <a:solidFill>
                   <a:srgbClr val="595959"/>
                 </a:solidFill>
@@ -6647,7 +6647,7 @@
               </a:rPr>
               <a:t>Productivity</a:t>
             </a:r>
-            <a:endParaRPr lang="en-US" sz="1550" dirty="0"/>
+            <a:endParaRPr lang="en-US" sz="1700" dirty="0"/>
           </a:p>
         </p:txBody>
       </p:sp>
@@ -6696,7 +6696,7 @@
               <a:buNone/>
             </a:pPr>
             <a:r>
-              <a:rPr lang="en-US" sz="1550" dirty="0">
+              <a:rPr lang="en-US" sz="1700" dirty="0">
                 <a:solidFill>
                   <a:srgbClr val="595959"/>
                 </a:solidFill>
@@ -6706,7 +6706,7 @@
               </a:rPr>
               <a:t>Close</a:t>
             </a:r>
-            <a:endParaRPr lang="en-US" sz="1550" dirty="0"/>
+            <a:endParaRPr lang="en-US" sz="1700" dirty="0"/>
           </a:p>
         </p:txBody>
       </p:sp>
@@ -6928,7 +6928,7 @@
               <a:buNone/>
             </a:pPr>
             <a:r>
-              <a:rPr lang="en-US" sz="1550" dirty="0">
+              <a:rPr lang="en-US" sz="1700" dirty="0">
                 <a:solidFill>
                   <a:srgbClr val="595959"/>
                 </a:solidFill>
@@ -6938,7 +6938,7 @@
               </a:rPr>
               <a:t>Gross</a:t>
             </a:r>
-            <a:endParaRPr lang="en-US" sz="1550" dirty="0"/>
+            <a:endParaRPr lang="en-US" sz="1700" dirty="0"/>
           </a:p>
         </p:txBody>
       </p:sp>
@@ -6987,7 +6987,7 @@
               <a:buNone/>
             </a:pPr>
             <a:r>
-              <a:rPr lang="en-US" sz="1550" dirty="0">
+              <a:rPr lang="en-US" sz="1700" dirty="0">
                 <a:solidFill>
                   <a:srgbClr val="595959"/>
                 </a:solidFill>
@@ -6997,7 +6997,7 @@
               </a:rPr>
               <a:t>Profitability</a:t>
             </a:r>
-            <a:endParaRPr lang="en-US" sz="1550" dirty="0"/>
+            <a:endParaRPr lang="en-US" sz="1700" dirty="0"/>
           </a:p>
         </p:txBody>
       </p:sp>
@@ -7046,7 +7046,7 @@
               <a:buNone/>
             </a:pPr>
             <a:r>
-              <a:rPr lang="en-US" sz="1550" dirty="0">
+              <a:rPr lang="en-US" sz="1700" dirty="0">
                 <a:solidFill>
                   <a:srgbClr val="595959"/>
                 </a:solidFill>
@@ -7056,7 +7056,7 @@
               </a:rPr>
               <a:t>CP Engine</a:t>
             </a:r>
-            <a:endParaRPr lang="en-US" sz="1550" dirty="0"/>
+            <a:endParaRPr lang="en-US" sz="1700" dirty="0"/>
           </a:p>
         </p:txBody>
       </p:sp>
@@ -7105,7 +7105,7 @@
               <a:buNone/>
             </a:pPr>
             <a:r>
-              <a:rPr lang="en-US" sz="1550" dirty="0">
+              <a:rPr lang="en-US" sz="1700" dirty="0">
                 <a:solidFill>
                   <a:srgbClr val="595959"/>
                 </a:solidFill>
@@ -7115,7 +7115,7 @@
               </a:rPr>
               <a:t>Labor Mix</a:t>
             </a:r>
-            <a:endParaRPr lang="en-US" sz="1550" dirty="0"/>
+            <a:endParaRPr lang="en-US" sz="1700" dirty="0"/>
           </a:p>
         </p:txBody>
       </p:sp>
@@ -7164,7 +7164,7 @@
               <a:buNone/>
             </a:pPr>
             <a:r>
-              <a:rPr lang="en-US" sz="1550" b="1" dirty="0">
+              <a:rPr lang="en-US" sz="1700" b="1" dirty="0">
                 <a:solidFill>
                   <a:srgbClr val="1A1A1A"/>
                 </a:solidFill>
@@ -7174,7 +7174,7 @@
               </a:rPr>
               <a:t>Opcodes</a:t>
             </a:r>
-            <a:endParaRPr lang="en-US" sz="1550" dirty="0"/>
+            <a:endParaRPr lang="en-US" sz="1700" dirty="0"/>
           </a:p>
         </p:txBody>
       </p:sp>
@@ -7223,7 +7223,7 @@
               <a:buNone/>
             </a:pPr>
             <a:r>
-              <a:rPr lang="en-US" sz="1550" dirty="0">
+              <a:rPr lang="en-US" sz="1700" dirty="0">
                 <a:solidFill>
                   <a:srgbClr val="595959"/>
                 </a:solidFill>
@@ -7231,9 +7231,9 @@
                 <a:ea typeface="Inter" pitchFamily="34" charset="-122"/>
                 <a:cs typeface="Inter" pitchFamily="34" charset="-120"/>
               </a:rPr>
-              <a:t>Warranty &amp; Internal</a:t>
-            </a:r>
-            <a:endParaRPr lang="en-US" sz="1550" dirty="0"/>
+              <a:t>Warranty</a:t>
+            </a:r>
+            <a:endParaRPr lang="en-US" sz="1700" dirty="0"/>
           </a:p>
         </p:txBody>
       </p:sp>
@@ -7282,7 +7282,7 @@
               <a:buNone/>
             </a:pPr>
             <a:r>
-              <a:rPr lang="en-US" sz="1550" dirty="0">
+              <a:rPr lang="en-US" sz="1700" dirty="0">
                 <a:solidFill>
                   <a:srgbClr val="595959"/>
                 </a:solidFill>
@@ -7292,7 +7292,7 @@
               </a:rPr>
               <a:t>Productivity</a:t>
             </a:r>
-            <a:endParaRPr lang="en-US" sz="1550" dirty="0"/>
+            <a:endParaRPr lang="en-US" sz="1700" dirty="0"/>
           </a:p>
         </p:txBody>
       </p:sp>
@@ -7341,7 +7341,7 @@
               <a:buNone/>
             </a:pPr>
             <a:r>
-              <a:rPr lang="en-US" sz="1550" dirty="0">
+              <a:rPr lang="en-US" sz="1700" dirty="0">
                 <a:solidFill>
                   <a:srgbClr val="595959"/>
                 </a:solidFill>
@@ -7351,7 +7351,7 @@
               </a:rPr>
               <a:t>Close</a:t>
             </a:r>
-            <a:endParaRPr lang="en-US" sz="1550" dirty="0"/>
+            <a:endParaRPr lang="en-US" sz="1700" dirty="0"/>
           </a:p>
         </p:txBody>
       </p:sp>
@@ -7475,7 +7475,7 @@
               <a:buNone/>
             </a:pPr>
             <a:r>
-              <a:rPr lang="en-US" sz="7200" b="1" dirty="0">
+              <a:rPr lang="en-US" sz="7600" b="1" dirty="0">
                 <a:solidFill>
                   <a:srgbClr val="1A1A1A"/>
                 </a:solidFill>
@@ -7483,9 +7483,9 @@
                 <a:ea typeface="Inter" pitchFamily="34" charset="-122"/>
                 <a:cs typeface="Inter" pitchFamily="34" charset="-120"/>
               </a:rPr>
-              <a:t>Warranty &amp; Internal</a:t>
-            </a:r>
-            <a:endParaRPr lang="en-US" sz="7200" dirty="0"/>
+              <a:t>Warranty</a:t>
+            </a:r>
+            <a:endParaRPr lang="en-US" sz="7600" dirty="0"/>
           </a:p>
         </p:txBody>
       </p:sp>
@@ -7522,7 +7522,7 @@
                 <a:ea typeface="Inter" pitchFamily="34" charset="-122"/>
                 <a:cs typeface="Inter" pitchFamily="34" charset="-120"/>
               </a:rPr>
-              <a:t>Rate increases   ·   Warranty audits   ·   Warranty ELR   ·   Internal ELR</a:t>
+              <a:t>Rate increases   ·   Warranty ELR   ·   Parts margin   ·   Warranty audits</a:t>
             </a:r>
             <a:endParaRPr lang="en-US" sz="2200" dirty="0"/>
           </a:p>
@@ -7573,7 +7573,7 @@
               <a:buNone/>
             </a:pPr>
             <a:r>
-              <a:rPr lang="en-US" sz="1550" dirty="0">
+              <a:rPr lang="en-US" sz="1700" dirty="0">
                 <a:solidFill>
                   <a:srgbClr val="595959"/>
                 </a:solidFill>
@@ -7583,7 +7583,7 @@
               </a:rPr>
               <a:t>Gross</a:t>
             </a:r>
-            <a:endParaRPr lang="en-US" sz="1550" dirty="0"/>
+            <a:endParaRPr lang="en-US" sz="1700" dirty="0"/>
           </a:p>
         </p:txBody>
       </p:sp>
@@ -7632,7 +7632,7 @@
               <a:buNone/>
             </a:pPr>
             <a:r>
-              <a:rPr lang="en-US" sz="1550" dirty="0">
+              <a:rPr lang="en-US" sz="1700" dirty="0">
                 <a:solidFill>
                   <a:srgbClr val="595959"/>
                 </a:solidFill>
@@ -7642,7 +7642,7 @@
               </a:rPr>
               <a:t>Profitability</a:t>
             </a:r>
-            <a:endParaRPr lang="en-US" sz="1550" dirty="0"/>
+            <a:endParaRPr lang="en-US" sz="1700" dirty="0"/>
           </a:p>
         </p:txBody>
       </p:sp>
@@ -7691,7 +7691,7 @@
               <a:buNone/>
             </a:pPr>
             <a:r>
-              <a:rPr lang="en-US" sz="1550" dirty="0">
+              <a:rPr lang="en-US" sz="1700" dirty="0">
                 <a:solidFill>
                   <a:srgbClr val="595959"/>
                 </a:solidFill>
@@ -7701,7 +7701,7 @@
               </a:rPr>
               <a:t>CP Engine</a:t>
             </a:r>
-            <a:endParaRPr lang="en-US" sz="1550" dirty="0"/>
+            <a:endParaRPr lang="en-US" sz="1700" dirty="0"/>
           </a:p>
         </p:txBody>
       </p:sp>
@@ -7750,7 +7750,7 @@
               <a:buNone/>
             </a:pPr>
             <a:r>
-              <a:rPr lang="en-US" sz="1550" dirty="0">
+              <a:rPr lang="en-US" sz="1700" dirty="0">
                 <a:solidFill>
                   <a:srgbClr val="595959"/>
                 </a:solidFill>
@@ -7760,7 +7760,7 @@
               </a:rPr>
               <a:t>Labor Mix</a:t>
             </a:r>
-            <a:endParaRPr lang="en-US" sz="1550" dirty="0"/>
+            <a:endParaRPr lang="en-US" sz="1700" dirty="0"/>
           </a:p>
         </p:txBody>
       </p:sp>
@@ -7809,7 +7809,7 @@
               <a:buNone/>
             </a:pPr>
             <a:r>
-              <a:rPr lang="en-US" sz="1550" dirty="0">
+              <a:rPr lang="en-US" sz="1700" dirty="0">
                 <a:solidFill>
                   <a:srgbClr val="595959"/>
                 </a:solidFill>
@@ -7819,7 +7819,7 @@
               </a:rPr>
               <a:t>Opcodes</a:t>
             </a:r>
-            <a:endParaRPr lang="en-US" sz="1550" dirty="0"/>
+            <a:endParaRPr lang="en-US" sz="1700" dirty="0"/>
           </a:p>
         </p:txBody>
       </p:sp>
@@ -7868,7 +7868,7 @@
               <a:buNone/>
             </a:pPr>
             <a:r>
-              <a:rPr lang="en-US" sz="1550" b="1" dirty="0">
+              <a:rPr lang="en-US" sz="1700" b="1" dirty="0">
                 <a:solidFill>
                   <a:srgbClr val="1A1A1A"/>
                 </a:solidFill>
@@ -7876,9 +7876,9 @@
                 <a:ea typeface="Inter" pitchFamily="34" charset="-122"/>
                 <a:cs typeface="Inter" pitchFamily="34" charset="-120"/>
               </a:rPr>
-              <a:t>Warranty &amp; Internal</a:t>
-            </a:r>
-            <a:endParaRPr lang="en-US" sz="1550" dirty="0"/>
+              <a:t>Warranty</a:t>
+            </a:r>
+            <a:endParaRPr lang="en-US" sz="1700" dirty="0"/>
           </a:p>
         </p:txBody>
       </p:sp>
@@ -7927,7 +7927,7 @@
               <a:buNone/>
             </a:pPr>
             <a:r>
-              <a:rPr lang="en-US" sz="1550" dirty="0">
+              <a:rPr lang="en-US" sz="1700" dirty="0">
                 <a:solidFill>
                   <a:srgbClr val="595959"/>
                 </a:solidFill>
@@ -7937,7 +7937,7 @@
               </a:rPr>
               <a:t>Productivity</a:t>
             </a:r>
-            <a:endParaRPr lang="en-US" sz="1550" dirty="0"/>
+            <a:endParaRPr lang="en-US" sz="1700" dirty="0"/>
           </a:p>
         </p:txBody>
       </p:sp>
@@ -7986,7 +7986,7 @@
               <a:buNone/>
             </a:pPr>
             <a:r>
-              <a:rPr lang="en-US" sz="1550" dirty="0">
+              <a:rPr lang="en-US" sz="1700" dirty="0">
                 <a:solidFill>
                   <a:srgbClr val="595959"/>
                 </a:solidFill>
@@ -7996,7 +7996,7 @@
               </a:rPr>
               <a:t>Close</a:t>
             </a:r>
-            <a:endParaRPr lang="en-US" sz="1550" dirty="0"/>
+            <a:endParaRPr lang="en-US" sz="1700" dirty="0"/>
           </a:p>
         </p:txBody>
       </p:sp>
@@ -8218,7 +8218,7 @@
               <a:buNone/>
             </a:pPr>
             <a:r>
-              <a:rPr lang="en-US" sz="1550" dirty="0">
+              <a:rPr lang="en-US" sz="1700" dirty="0">
                 <a:solidFill>
                   <a:srgbClr val="595959"/>
                 </a:solidFill>
@@ -8228,7 +8228,7 @@
               </a:rPr>
               <a:t>Gross</a:t>
             </a:r>
-            <a:endParaRPr lang="en-US" sz="1550" dirty="0"/>
+            <a:endParaRPr lang="en-US" sz="1700" dirty="0"/>
           </a:p>
         </p:txBody>
       </p:sp>
@@ -8277,7 +8277,7 @@
               <a:buNone/>
             </a:pPr>
             <a:r>
-              <a:rPr lang="en-US" sz="1550" dirty="0">
+              <a:rPr lang="en-US" sz="1700" dirty="0">
                 <a:solidFill>
                   <a:srgbClr val="595959"/>
                 </a:solidFill>
@@ -8287,7 +8287,7 @@
               </a:rPr>
               <a:t>Profitability</a:t>
             </a:r>
-            <a:endParaRPr lang="en-US" sz="1550" dirty="0"/>
+            <a:endParaRPr lang="en-US" sz="1700" dirty="0"/>
           </a:p>
         </p:txBody>
       </p:sp>
@@ -8336,7 +8336,7 @@
               <a:buNone/>
             </a:pPr>
             <a:r>
-              <a:rPr lang="en-US" sz="1550" dirty="0">
+              <a:rPr lang="en-US" sz="1700" dirty="0">
                 <a:solidFill>
                   <a:srgbClr val="595959"/>
                 </a:solidFill>
@@ -8346,7 +8346,7 @@
               </a:rPr>
               <a:t>CP Engine</a:t>
             </a:r>
-            <a:endParaRPr lang="en-US" sz="1550" dirty="0"/>
+            <a:endParaRPr lang="en-US" sz="1700" dirty="0"/>
           </a:p>
         </p:txBody>
       </p:sp>
@@ -8395,7 +8395,7 @@
               <a:buNone/>
             </a:pPr>
             <a:r>
-              <a:rPr lang="en-US" sz="1550" dirty="0">
+              <a:rPr lang="en-US" sz="1700" dirty="0">
                 <a:solidFill>
                   <a:srgbClr val="595959"/>
                 </a:solidFill>
@@ -8405,7 +8405,7 @@
               </a:rPr>
               <a:t>Labor Mix</a:t>
             </a:r>
-            <a:endParaRPr lang="en-US" sz="1550" dirty="0"/>
+            <a:endParaRPr lang="en-US" sz="1700" dirty="0"/>
           </a:p>
         </p:txBody>
       </p:sp>
@@ -8454,7 +8454,7 @@
               <a:buNone/>
             </a:pPr>
             <a:r>
-              <a:rPr lang="en-US" sz="1550" dirty="0">
+              <a:rPr lang="en-US" sz="1700" dirty="0">
                 <a:solidFill>
                   <a:srgbClr val="595959"/>
                 </a:solidFill>
@@ -8464,7 +8464,7 @@
               </a:rPr>
               <a:t>Opcodes</a:t>
             </a:r>
-            <a:endParaRPr lang="en-US" sz="1550" dirty="0"/>
+            <a:endParaRPr lang="en-US" sz="1700" dirty="0"/>
           </a:p>
         </p:txBody>
       </p:sp>
@@ -8513,7 +8513,7 @@
               <a:buNone/>
             </a:pPr>
             <a:r>
-              <a:rPr lang="en-US" sz="1550" dirty="0">
+              <a:rPr lang="en-US" sz="1700" dirty="0">
                 <a:solidFill>
                   <a:srgbClr val="595959"/>
                 </a:solidFill>
@@ -8521,9 +8521,9 @@
                 <a:ea typeface="Inter" pitchFamily="34" charset="-122"/>
                 <a:cs typeface="Inter" pitchFamily="34" charset="-120"/>
               </a:rPr>
-              <a:t>Warranty &amp; Internal</a:t>
-            </a:r>
-            <a:endParaRPr lang="en-US" sz="1550" dirty="0"/>
+              <a:t>Warranty</a:t>
+            </a:r>
+            <a:endParaRPr lang="en-US" sz="1700" dirty="0"/>
           </a:p>
         </p:txBody>
       </p:sp>
@@ -8572,7 +8572,7 @@
               <a:buNone/>
             </a:pPr>
             <a:r>
-              <a:rPr lang="en-US" sz="1550" b="1" dirty="0">
+              <a:rPr lang="en-US" sz="1700" b="1" dirty="0">
                 <a:solidFill>
                   <a:srgbClr val="1A1A1A"/>
                 </a:solidFill>
@@ -8582,7 +8582,7 @@
               </a:rPr>
               <a:t>Productivity</a:t>
             </a:r>
-            <a:endParaRPr lang="en-US" sz="1550" dirty="0"/>
+            <a:endParaRPr lang="en-US" sz="1700" dirty="0"/>
           </a:p>
         </p:txBody>
       </p:sp>
@@ -8631,7 +8631,7 @@
               <a:buNone/>
             </a:pPr>
             <a:r>
-              <a:rPr lang="en-US" sz="1550" dirty="0">
+              <a:rPr lang="en-US" sz="1700" dirty="0">
                 <a:solidFill>
                   <a:srgbClr val="595959"/>
                 </a:solidFill>
@@ -8641,7 +8641,7 @@
               </a:rPr>
               <a:t>Close</a:t>
             </a:r>
-            <a:endParaRPr lang="en-US" sz="1550" dirty="0"/>
+            <a:endParaRPr lang="en-US" sz="1700" dirty="0"/>
           </a:p>
         </p:txBody>
       </p:sp>

</xml_diff>

<commit_message>
MPI and video completion by store (Jul-Sep, store-reported) in Opcode Benchmarks; photo % in Open Decisions
Co-Authored-By: Claude Opus 5.5 <noreply@anthropic.com>
Claude-Session: https://claude.ai/code/session_01Xa4nFVxuQGXmHARGph9WhS
</commit_message>
<xml_diff>
--- a/day2-deck/decks/Day 2 Opening - Day 1 Style.pptx
+++ b/day2-deck/decks/Day 2 Opening - Day 1 Style.pptx
@@ -688,7 +688,7 @@
           <a:p>
             <a:r>
               <a:rPr lang="en-US" dirty="0"/>
-              <a:t>For review with Tommy, not for the room. Every slide built but not placed in the deck: alternate versions of slides already in it, and slides not yet decided on. In deck order: Gross Trend options A / B / B+Q4, Store Records (six designs), Door Rate options A-B, CP vs Internal GP % options A-B, Headcount trend, Best Techs option C, Who's Moving Now alternate versions, Most Improved v1. Pick what moves into the deck, then delete this section before the meeting.</a:t>
+              <a:t>For review with Tommy, not for the room. Every slide built but not placed in the deck: alternate versions of slides already in it, and slides not yet decided on. In deck order: Gross Trend options A / B / B+Q4, Store Records (six designs), Door Rate options A-B, CP vs Internal GP % options A-B, Photo completion % (optional measure), Headcount trend, Best Techs option C, Who's Moving Now alternate versions, Most Improved v1. Pick what moves into the deck, then delete this section before the meeting.</a:t>
             </a:r>
             <a:endParaRPr lang="en-US" dirty="0"/>
           </a:p>
@@ -2738,7 +2738,7 @@
                 <a:ea typeface="Inter" pitchFamily="34" charset="-122"/>
                 <a:cs typeface="Inter" pitchFamily="34" charset="-120"/>
               </a:rPr>
-              <a:t>Gross &amp; records   ·   Door rate   ·   CP vs internal   ·   Best techs   ·   Most improved</a:t>
+              <a:t>Trends &amp; records   ·   Door rate   ·   CP vs internal   ·   Photo %   ·   Best techs</a:t>
             </a:r>
             <a:endParaRPr lang="en-US" sz="2200" dirty="0"/>
           </a:p>
@@ -3653,7 +3653,7 @@
                 <a:ea typeface="Inter" pitchFamily="34" charset="-122"/>
                 <a:cs typeface="Inter" pitchFamily="34" charset="-120"/>
               </a:rPr>
-              <a:t>Alignment, balance, brake fluid and fuel.</a:t>
+              <a:t>MPI and video, then alignment, balance, brake fluid and fuel.</a:t>
             </a:r>
             <a:endParaRPr lang="en-US" sz="1400" dirty="0"/>
           </a:p>
@@ -6877,7 +6877,7 @@
                 <a:ea typeface="Inter" pitchFamily="34" charset="-122"/>
                 <a:cs typeface="Inter" pitchFamily="34" charset="-120"/>
               </a:rPr>
-              <a:t>Alignment 15%   ·   Balance 15%   ·   Brake fluid 10%   ·   Fuel service 7.5%</a:t>
+              <a:t>MPI 90%   ·   Alignment 15%   ·   Balance 15%   ·   Brake fluid 10%   ·   Fuel 7.5%</a:t>
             </a:r>
             <a:endParaRPr lang="en-US" sz="2200" dirty="0"/>
           </a:p>

</xml_diff>

<commit_message>
Open Decisions: remove Best Techs option C
Co-Authored-By: Claude Opus 5.5 <noreply@anthropic.com>
Claude-Session: https://claude.ai/code/session_01Xa4nFVxuQGXmHARGph9WhS
</commit_message>
<xml_diff>
--- a/day2-deck/decks/Day 2 Opening - Day 1 Style.pptx
+++ b/day2-deck/decks/Day 2 Opening - Day 1 Style.pptx
@@ -688,7 +688,7 @@
           <a:p>
             <a:r>
               <a:rPr lang="en-US" dirty="0"/>
-              <a:t>For review with Tommy, not for the room. Every slide built but not placed in the deck: alternate versions of slides already in it, and slides not yet decided on. In deck order: Gross Trend option A parts table and option B+Q4, Store Records (five designs), Door Rate option A, CP vs Internal GP % option A, Photo completion % (optional measure), Best Techs option C, Who's Moving Now alternate versions, Most Improved v1. Pick what moves into the deck, then delete this section before the meeting.</a:t>
+              <a:t>For review with Tommy, not for the room. Every slide built but not placed in the deck: alternate versions of slides already in it, and slides not yet decided on. In deck order: Gross Trend option A parts table and option B+Q4, Store Records (five designs), Door Rate option A, CP vs Internal GP % option A, Photo completion % (optional measure), Who's Moving Now alternate versions, Most Improved v1. Pick what moves into the deck, then delete this section before the meeting.</a:t>
             </a:r>
             <a:endParaRPr lang="en-US" dirty="0"/>
           </a:p>
@@ -2738,7 +2738,7 @@
                 <a:ea typeface="Inter" pitchFamily="34" charset="-122"/>
                 <a:cs typeface="Inter" pitchFamily="34" charset="-120"/>
               </a:rPr>
-              <a:t>Trends &amp; records   ·   Door rate   ·   CP vs internal   ·   Photo %   ·   Best techs</a:t>
+              <a:t>Trends &amp; records   ·   Door rate   ·   CP vs internal   ·   Photo %   ·   Most improved</a:t>
             </a:r>
             <a:endParaRPr lang="en-US" sz="2200" dirty="0"/>
           </a:p>

</xml_diff>

<commit_message>
Open Decisions: remove the last two Gross Trend option slides
Co-Authored-By: Claude Opus 5.5 <noreply@anthropic.com>
Claude-Session: https://claude.ai/code/session_01Xa4nFVxuQGXmHARGph9WhS
</commit_message>
<xml_diff>
--- a/day2-deck/decks/Day 2 Opening - Day 1 Style.pptx
+++ b/day2-deck/decks/Day 2 Opening - Day 1 Style.pptx
@@ -688,7 +688,7 @@
           <a:p>
             <a:r>
               <a:rPr lang="en-US" dirty="0"/>
-              <a:t>For review with Tommy, not for the room. Every slide built but not placed in the deck: alternate versions of slides already in it, and slides not yet decided on. In deck order: Gross Trend option A parts table and option B+Q4, Store Records (five designs), Door Rate option A, CP vs Internal GP % option A, Photo completion % (optional measure), Who's Moving Now alternate versions, Most Improved v1. Pick what moves into the deck, then delete this section before the meeting.</a:t>
+              <a:t>For review with Tommy, not for the room. Every slide built but not placed in the deck: alternate versions of slides already in it, and slides not yet decided on. In deck order: Store Records (five designs), Door Rate option A, CP vs Internal GP % option A, Photo completion % (optional measure), Who's Moving Now alternate versions, Most Improved v1. Pick what moves into the deck, then delete this section before the meeting.</a:t>
             </a:r>
             <a:endParaRPr lang="en-US" dirty="0"/>
           </a:p>
@@ -2738,7 +2738,7 @@
                 <a:ea typeface="Inter" pitchFamily="34" charset="-122"/>
                 <a:cs typeface="Inter" pitchFamily="34" charset="-120"/>
               </a:rPr>
-              <a:t>Trends &amp; records   ·   Door rate   ·   CP vs internal   ·   Photo %   ·   Most improved</a:t>
+              <a:t>Store records   ·   Door rate   ·   CP vs internal   ·   Photo %   ·   Most improved</a:t>
             </a:r>
             <a:endParaRPr lang="en-US" sz="2200" dirty="0"/>
           </a:p>

</xml_diff>

<commit_message>
Agenda: Opcode Benchmarks 04, Labor Mix 05, Productivity 06, Warranty 07
Co-Authored-By: Claude Opus 5.5 <noreply@anthropic.com>
Claude-Session: https://claude.ai/code/session_01Xa4nFVxuQGXmHARGph9WhS
</commit_message>
<xml_diff>
--- a/day2-deck/decks/Day 2 Opening - Day 1 Style.pptx
+++ b/day2-deck/decks/Day 2 Opening - Day 1 Style.pptx
@@ -2329,7 +2329,7 @@
                 <a:ea typeface="Inter" pitchFamily="34" charset="-122"/>
                 <a:cs typeface="Inter" pitchFamily="34" charset="-120"/>
               </a:rPr>
-              <a:t>Labor Mix</a:t>
+              <a:t>Opcodes</a:t>
             </a:r>
             <a:endParaRPr lang="en-US" sz="1700" dirty="0"/>
           </a:p>
@@ -2388,7 +2388,7 @@
                 <a:ea typeface="Inter" pitchFamily="34" charset="-122"/>
                 <a:cs typeface="Inter" pitchFamily="34" charset="-120"/>
               </a:rPr>
-              <a:t>Opcodes</a:t>
+              <a:t>Labor Mix</a:t>
             </a:r>
             <a:endParaRPr lang="en-US" sz="1700" dirty="0"/>
           </a:p>
@@ -2447,7 +2447,7 @@
                 <a:ea typeface="Inter" pitchFamily="34" charset="-122"/>
                 <a:cs typeface="Inter" pitchFamily="34" charset="-120"/>
               </a:rPr>
-              <a:t>Warranty</a:t>
+              <a:t>Productivity</a:t>
             </a:r>
             <a:endParaRPr lang="en-US" sz="1700" dirty="0"/>
           </a:p>
@@ -2506,7 +2506,7 @@
                 <a:ea typeface="Inter" pitchFamily="34" charset="-122"/>
                 <a:cs typeface="Inter" pitchFamily="34" charset="-120"/>
               </a:rPr>
-              <a:t>Productivity</a:t>
+              <a:t>Warranty</a:t>
             </a:r>
             <a:endParaRPr lang="en-US" sz="1700" dirty="0"/>
           </a:p>
@@ -3457,7 +3457,7 @@
                 <a:ea typeface="Inter" pitchFamily="34" charset="-122"/>
                 <a:cs typeface="Inter" pitchFamily="34" charset="-120"/>
               </a:rPr>
-              <a:t>Labor Mix</a:t>
+              <a:t>Opcode Benchmarks</a:t>
             </a:r>
             <a:endParaRPr lang="en-US" sz="1700" dirty="0"/>
           </a:p>
@@ -3496,7 +3496,7 @@
                 <a:ea typeface="Inter" pitchFamily="34" charset="-122"/>
                 <a:cs typeface="Inter" pitchFamily="34" charset="-120"/>
               </a:rPr>
-              <a:t>Pay type and internal, maintenance and repair mix.</a:t>
+              <a:t>MPI and video, then alignment, balance, brake fluid and fuel.</a:t>
             </a:r>
             <a:endParaRPr lang="en-US" sz="1400" dirty="0"/>
           </a:p>
@@ -3614,7 +3614,7 @@
                 <a:ea typeface="Inter" pitchFamily="34" charset="-122"/>
                 <a:cs typeface="Inter" pitchFamily="34" charset="-120"/>
               </a:rPr>
-              <a:t>Opcode Benchmarks</a:t>
+              <a:t>Labor Mix</a:t>
             </a:r>
             <a:endParaRPr lang="en-US" sz="1700" dirty="0"/>
           </a:p>
@@ -3653,7 +3653,7 @@
                 <a:ea typeface="Inter" pitchFamily="34" charset="-122"/>
                 <a:cs typeface="Inter" pitchFamily="34" charset="-120"/>
               </a:rPr>
-              <a:t>MPI and video, then alignment, balance, brake fluid and fuel.</a:t>
+              <a:t>Pay type and internal, maintenance and repair mix.</a:t>
             </a:r>
             <a:endParaRPr lang="en-US" sz="1400" dirty="0"/>
           </a:p>
@@ -3771,7 +3771,7 @@
                 <a:ea typeface="Inter" pitchFamily="34" charset="-122"/>
                 <a:cs typeface="Inter" pitchFamily="34" charset="-120"/>
               </a:rPr>
-              <a:t>Warranty</a:t>
+              <a:t>Productivity</a:t>
             </a:r>
             <a:endParaRPr lang="en-US" sz="1700" dirty="0"/>
           </a:p>
@@ -3810,7 +3810,7 @@
                 <a:ea typeface="Inter" pitchFamily="34" charset="-122"/>
                 <a:cs typeface="Inter" pitchFamily="34" charset="-120"/>
               </a:rPr>
-              <a:t>Rate increases, warranty rate and parts margin, audits and compliance.</a:t>
+              <a:t>Gross per employee, headcount and technician proficiency.</a:t>
             </a:r>
             <a:endParaRPr lang="en-US" sz="1400" dirty="0"/>
           </a:p>
@@ -3928,7 +3928,7 @@
                 <a:ea typeface="Inter" pitchFamily="34" charset="-122"/>
                 <a:cs typeface="Inter" pitchFamily="34" charset="-120"/>
               </a:rPr>
-              <a:t>Productivity</a:t>
+              <a:t>Warranty</a:t>
             </a:r>
             <a:endParaRPr lang="en-US" sz="1700" dirty="0"/>
           </a:p>
@@ -3967,7 +3967,7 @@
                 <a:ea typeface="Inter" pitchFamily="34" charset="-122"/>
                 <a:cs typeface="Inter" pitchFamily="34" charset="-120"/>
               </a:rPr>
-              <a:t>Gross per employee, headcount and technician proficiency.</a:t>
+              <a:t>Rate increases, warranty rate and parts margin, audits and compliance.</a:t>
             </a:r>
             <a:endParaRPr lang="en-US" sz="1400" dirty="0"/>
           </a:p>
@@ -4533,7 +4533,7 @@
                 <a:ea typeface="Inter" pitchFamily="34" charset="-122"/>
                 <a:cs typeface="Inter" pitchFamily="34" charset="-120"/>
               </a:rPr>
-              <a:t>Labor Mix</a:t>
+              <a:t>Opcodes</a:t>
             </a:r>
             <a:endParaRPr lang="en-US" sz="1700" dirty="0"/>
           </a:p>
@@ -4592,7 +4592,7 @@
                 <a:ea typeface="Inter" pitchFamily="34" charset="-122"/>
                 <a:cs typeface="Inter" pitchFamily="34" charset="-120"/>
               </a:rPr>
-              <a:t>Opcodes</a:t>
+              <a:t>Labor Mix</a:t>
             </a:r>
             <a:endParaRPr lang="en-US" sz="1700" dirty="0"/>
           </a:p>
@@ -4651,7 +4651,7 @@
                 <a:ea typeface="Inter" pitchFamily="34" charset="-122"/>
                 <a:cs typeface="Inter" pitchFamily="34" charset="-120"/>
               </a:rPr>
-              <a:t>Warranty</a:t>
+              <a:t>Productivity</a:t>
             </a:r>
             <a:endParaRPr lang="en-US" sz="1700" dirty="0"/>
           </a:p>
@@ -4710,7 +4710,7 @@
                 <a:ea typeface="Inter" pitchFamily="34" charset="-122"/>
                 <a:cs typeface="Inter" pitchFamily="34" charset="-120"/>
               </a:rPr>
-              <a:t>Productivity</a:t>
+              <a:t>Warranty</a:t>
             </a:r>
             <a:endParaRPr lang="en-US" sz="1700" dirty="0"/>
           </a:p>
@@ -5178,7 +5178,7 @@
                 <a:ea typeface="Inter" pitchFamily="34" charset="-122"/>
                 <a:cs typeface="Inter" pitchFamily="34" charset="-120"/>
               </a:rPr>
-              <a:t>Labor Mix</a:t>
+              <a:t>Opcodes</a:t>
             </a:r>
             <a:endParaRPr lang="en-US" sz="1700" dirty="0"/>
           </a:p>
@@ -5237,7 +5237,7 @@
                 <a:ea typeface="Inter" pitchFamily="34" charset="-122"/>
                 <a:cs typeface="Inter" pitchFamily="34" charset="-120"/>
               </a:rPr>
-              <a:t>Opcodes</a:t>
+              <a:t>Labor Mix</a:t>
             </a:r>
             <a:endParaRPr lang="en-US" sz="1700" dirty="0"/>
           </a:p>
@@ -5296,7 +5296,7 @@
                 <a:ea typeface="Inter" pitchFamily="34" charset="-122"/>
                 <a:cs typeface="Inter" pitchFamily="34" charset="-120"/>
               </a:rPr>
-              <a:t>Warranty</a:t>
+              <a:t>Productivity</a:t>
             </a:r>
             <a:endParaRPr lang="en-US" sz="1700" dirty="0"/>
           </a:p>
@@ -5355,7 +5355,7 @@
                 <a:ea typeface="Inter" pitchFamily="34" charset="-122"/>
                 <a:cs typeface="Inter" pitchFamily="34" charset="-120"/>
               </a:rPr>
-              <a:t>Productivity</a:t>
+              <a:t>Warranty</a:t>
             </a:r>
             <a:endParaRPr lang="en-US" sz="1700" dirty="0"/>
           </a:p>
@@ -5823,7 +5823,7 @@
                 <a:ea typeface="Inter" pitchFamily="34" charset="-122"/>
                 <a:cs typeface="Inter" pitchFamily="34" charset="-120"/>
               </a:rPr>
-              <a:t>Labor Mix</a:t>
+              <a:t>Opcodes</a:t>
             </a:r>
             <a:endParaRPr lang="en-US" sz="1700" dirty="0"/>
           </a:p>
@@ -5882,7 +5882,7 @@
                 <a:ea typeface="Inter" pitchFamily="34" charset="-122"/>
                 <a:cs typeface="Inter" pitchFamily="34" charset="-120"/>
               </a:rPr>
-              <a:t>Opcodes</a:t>
+              <a:t>Labor Mix</a:t>
             </a:r>
             <a:endParaRPr lang="en-US" sz="1700" dirty="0"/>
           </a:p>
@@ -5941,7 +5941,7 @@
                 <a:ea typeface="Inter" pitchFamily="34" charset="-122"/>
                 <a:cs typeface="Inter" pitchFamily="34" charset="-120"/>
               </a:rPr>
-              <a:t>Warranty</a:t>
+              <a:t>Productivity</a:t>
             </a:r>
             <a:endParaRPr lang="en-US" sz="1700" dirty="0"/>
           </a:p>
@@ -6000,7 +6000,7 @@
                 <a:ea typeface="Inter" pitchFamily="34" charset="-122"/>
                 <a:cs typeface="Inter" pitchFamily="34" charset="-120"/>
               </a:rPr>
-              <a:t>Productivity</a:t>
+              <a:t>Warranty</a:t>
             </a:r>
             <a:endParaRPr lang="en-US" sz="1700" dirty="0"/>
           </a:p>
@@ -6193,7 +6193,7 @@
                 <a:ea typeface="Inter" pitchFamily="34" charset="-122"/>
                 <a:cs typeface="Inter" pitchFamily="34" charset="-120"/>
               </a:rPr>
-              <a:t>Labor Mix</a:t>
+              <a:t>Opcode Benchmarks</a:t>
             </a:r>
             <a:endParaRPr lang="en-US" sz="7600" dirty="0"/>
           </a:p>
@@ -6232,7 +6232,7 @@
                 <a:ea typeface="Inter" pitchFamily="34" charset="-122"/>
                 <a:cs typeface="Inter" pitchFamily="34" charset="-120"/>
               </a:rPr>
-              <a:t>Pay type   ·   Internal rate &amp; margin   ·   Work type   ·   Op code descriptions</a:t>
+              <a:t>MPI 90%   ·   Alignment 15%   ·   Balance 15%   ·   Brake fluid 10%   ·   Fuel 7.5%</a:t>
             </a:r>
             <a:endParaRPr lang="en-US" sz="2200" dirty="0"/>
           </a:p>
@@ -6468,7 +6468,7 @@
                 <a:ea typeface="Inter" pitchFamily="34" charset="-122"/>
                 <a:cs typeface="Inter" pitchFamily="34" charset="-120"/>
               </a:rPr>
-              <a:t>Labor Mix</a:t>
+              <a:t>Opcodes</a:t>
             </a:r>
             <a:endParaRPr lang="en-US" sz="1700" dirty="0"/>
           </a:p>
@@ -6527,7 +6527,7 @@
                 <a:ea typeface="Inter" pitchFamily="34" charset="-122"/>
                 <a:cs typeface="Inter" pitchFamily="34" charset="-120"/>
               </a:rPr>
-              <a:t>Opcodes</a:t>
+              <a:t>Labor Mix</a:t>
             </a:r>
             <a:endParaRPr lang="en-US" sz="1700" dirty="0"/>
           </a:p>
@@ -6586,7 +6586,7 @@
                 <a:ea typeface="Inter" pitchFamily="34" charset="-122"/>
                 <a:cs typeface="Inter" pitchFamily="34" charset="-120"/>
               </a:rPr>
-              <a:t>Warranty</a:t>
+              <a:t>Productivity</a:t>
             </a:r>
             <a:endParaRPr lang="en-US" sz="1700" dirty="0"/>
           </a:p>
@@ -6645,7 +6645,7 @@
                 <a:ea typeface="Inter" pitchFamily="34" charset="-122"/>
                 <a:cs typeface="Inter" pitchFamily="34" charset="-120"/>
               </a:rPr>
-              <a:t>Productivity</a:t>
+              <a:t>Warranty</a:t>
             </a:r>
             <a:endParaRPr lang="en-US" sz="1700" dirty="0"/>
           </a:p>
@@ -6838,7 +6838,7 @@
                 <a:ea typeface="Inter" pitchFamily="34" charset="-122"/>
                 <a:cs typeface="Inter" pitchFamily="34" charset="-120"/>
               </a:rPr>
-              <a:t>Opcode Benchmarks</a:t>
+              <a:t>Labor Mix</a:t>
             </a:r>
             <a:endParaRPr lang="en-US" sz="7600" dirty="0"/>
           </a:p>
@@ -6877,7 +6877,7 @@
                 <a:ea typeface="Inter" pitchFamily="34" charset="-122"/>
                 <a:cs typeface="Inter" pitchFamily="34" charset="-120"/>
               </a:rPr>
-              <a:t>MPI 90%   ·   Alignment 15%   ·   Balance 15%   ·   Brake fluid 10%   ·   Fuel 7.5%</a:t>
+              <a:t>Pay type   ·   Internal rate &amp; margin   ·   Work type   ·   Op code descriptions</a:t>
             </a:r>
             <a:endParaRPr lang="en-US" sz="2200" dirty="0"/>
           </a:p>
@@ -7113,7 +7113,7 @@
                 <a:ea typeface="Inter" pitchFamily="34" charset="-122"/>
                 <a:cs typeface="Inter" pitchFamily="34" charset="-120"/>
               </a:rPr>
-              <a:t>Labor Mix</a:t>
+              <a:t>Opcodes</a:t>
             </a:r>
             <a:endParaRPr lang="en-US" sz="1700" dirty="0"/>
           </a:p>
@@ -7172,7 +7172,7 @@
                 <a:ea typeface="Inter" pitchFamily="34" charset="-122"/>
                 <a:cs typeface="Inter" pitchFamily="34" charset="-120"/>
               </a:rPr>
-              <a:t>Opcodes</a:t>
+              <a:t>Labor Mix</a:t>
             </a:r>
             <a:endParaRPr lang="en-US" sz="1700" dirty="0"/>
           </a:p>
@@ -7231,7 +7231,7 @@
                 <a:ea typeface="Inter" pitchFamily="34" charset="-122"/>
                 <a:cs typeface="Inter" pitchFamily="34" charset="-120"/>
               </a:rPr>
-              <a:t>Warranty</a:t>
+              <a:t>Productivity</a:t>
             </a:r>
             <a:endParaRPr lang="en-US" sz="1700" dirty="0"/>
           </a:p>
@@ -7290,7 +7290,7 @@
                 <a:ea typeface="Inter" pitchFamily="34" charset="-122"/>
                 <a:cs typeface="Inter" pitchFamily="34" charset="-120"/>
               </a:rPr>
-              <a:t>Productivity</a:t>
+              <a:t>Warranty</a:t>
             </a:r>
             <a:endParaRPr lang="en-US" sz="1700" dirty="0"/>
           </a:p>
@@ -7483,7 +7483,7 @@
                 <a:ea typeface="Inter" pitchFamily="34" charset="-122"/>
                 <a:cs typeface="Inter" pitchFamily="34" charset="-120"/>
               </a:rPr>
-              <a:t>Warranty</a:t>
+              <a:t>Productivity</a:t>
             </a:r>
             <a:endParaRPr lang="en-US" sz="7600" dirty="0"/>
           </a:p>
@@ -7522,7 +7522,7 @@
                 <a:ea typeface="Inter" pitchFamily="34" charset="-122"/>
                 <a:cs typeface="Inter" pitchFamily="34" charset="-120"/>
               </a:rPr>
-              <a:t>Rate increases   ·   Warranty ELR   ·   Parts margin   ·   Warranty audits</a:t>
+              <a:t>Gross per employee   ·   ROs per person   ·   Headcount   ·   Technician proficiency</a:t>
             </a:r>
             <a:endParaRPr lang="en-US" sz="2200" dirty="0"/>
           </a:p>
@@ -7758,7 +7758,7 @@
                 <a:ea typeface="Inter" pitchFamily="34" charset="-122"/>
                 <a:cs typeface="Inter" pitchFamily="34" charset="-120"/>
               </a:rPr>
-              <a:t>Labor Mix</a:t>
+              <a:t>Opcodes</a:t>
             </a:r>
             <a:endParaRPr lang="en-US" sz="1700" dirty="0"/>
           </a:p>
@@ -7817,7 +7817,7 @@
                 <a:ea typeface="Inter" pitchFamily="34" charset="-122"/>
                 <a:cs typeface="Inter" pitchFamily="34" charset="-120"/>
               </a:rPr>
-              <a:t>Opcodes</a:t>
+              <a:t>Labor Mix</a:t>
             </a:r>
             <a:endParaRPr lang="en-US" sz="1700" dirty="0"/>
           </a:p>
@@ -7876,7 +7876,7 @@
                 <a:ea typeface="Inter" pitchFamily="34" charset="-122"/>
                 <a:cs typeface="Inter" pitchFamily="34" charset="-120"/>
               </a:rPr>
-              <a:t>Warranty</a:t>
+              <a:t>Productivity</a:t>
             </a:r>
             <a:endParaRPr lang="en-US" sz="1700" dirty="0"/>
           </a:p>
@@ -7935,7 +7935,7 @@
                 <a:ea typeface="Inter" pitchFamily="34" charset="-122"/>
                 <a:cs typeface="Inter" pitchFamily="34" charset="-120"/>
               </a:rPr>
-              <a:t>Productivity</a:t>
+              <a:t>Warranty</a:t>
             </a:r>
             <a:endParaRPr lang="en-US" sz="1700" dirty="0"/>
           </a:p>
@@ -8128,7 +8128,7 @@
                 <a:ea typeface="Inter" pitchFamily="34" charset="-122"/>
                 <a:cs typeface="Inter" pitchFamily="34" charset="-120"/>
               </a:rPr>
-              <a:t>Productivity</a:t>
+              <a:t>Warranty</a:t>
             </a:r>
             <a:endParaRPr lang="en-US" sz="7600" dirty="0"/>
           </a:p>
@@ -8167,7 +8167,7 @@
                 <a:ea typeface="Inter" pitchFamily="34" charset="-122"/>
                 <a:cs typeface="Inter" pitchFamily="34" charset="-120"/>
               </a:rPr>
-              <a:t>Gross per employee   ·   ROs per person   ·   Headcount   ·   Technician proficiency</a:t>
+              <a:t>Rate increases   ·   Warranty ELR   ·   Parts margin   ·   Warranty audits</a:t>
             </a:r>
             <a:endParaRPr lang="en-US" sz="2200" dirty="0"/>
           </a:p>
@@ -8403,7 +8403,7 @@
                 <a:ea typeface="Inter" pitchFamily="34" charset="-122"/>
                 <a:cs typeface="Inter" pitchFamily="34" charset="-120"/>
               </a:rPr>
-              <a:t>Labor Mix</a:t>
+              <a:t>Opcodes</a:t>
             </a:r>
             <a:endParaRPr lang="en-US" sz="1700" dirty="0"/>
           </a:p>
@@ -8462,7 +8462,7 @@
                 <a:ea typeface="Inter" pitchFamily="34" charset="-122"/>
                 <a:cs typeface="Inter" pitchFamily="34" charset="-120"/>
               </a:rPr>
-              <a:t>Opcodes</a:t>
+              <a:t>Labor Mix</a:t>
             </a:r>
             <a:endParaRPr lang="en-US" sz="1700" dirty="0"/>
           </a:p>
@@ -8521,7 +8521,7 @@
                 <a:ea typeface="Inter" pitchFamily="34" charset="-122"/>
                 <a:cs typeface="Inter" pitchFamily="34" charset="-120"/>
               </a:rPr>
-              <a:t>Warranty</a:t>
+              <a:t>Productivity</a:t>
             </a:r>
             <a:endParaRPr lang="en-US" sz="1700" dirty="0"/>
           </a:p>
@@ -8580,7 +8580,7 @@
                 <a:ea typeface="Inter" pitchFamily="34" charset="-122"/>
                 <a:cs typeface="Inter" pitchFamily="34" charset="-120"/>
               </a:rPr>
-              <a:t>Productivity</a:t>
+              <a:t>Warranty</a:t>
             </a:r>
             <a:endParaRPr lang="en-US" sz="1700" dirty="0"/>
           </a:p>

</xml_diff>

<commit_message>
Customer Pay edits: explainer wording, slide moves, parts $ per RO out, Who's Moving Now charts to Open Decisions; luxury split options review
Co-Authored-By: Claude Opus 5.5 <noreply@anthropic.com>
Claude-Session: https://claude.ai/code/session_01Xa4nFVxuQGXmHARGph9WhS
</commit_message>
<xml_diff>
--- a/day2-deck/decks/Day 2 Opening - Day 1 Style.pptx
+++ b/day2-deck/decks/Day 2 Opening - Day 1 Style.pptx
@@ -688,7 +688,7 @@
           <a:p>
             <a:r>
               <a:rPr lang="en-US" dirty="0"/>
-              <a:t>For review with Tommy, not for the room. Every slide built but not placed in the deck: alternate versions of slides already in it, and slides not yet decided on. In deck order: Store Records (five designs), Door Rate option A, CP vs Internal GP % option A, Photo completion % (optional measure), Who's Moving Now alternate versions, Most Improved v1. Pick what moves into the deck, then delete this section before the meeting.</a:t>
+              <a:t>For review with Tommy, not for the room. Every slide built but not placed in the deck: alternate versions of slides already in it, and slides not yet decided on. In deck order: Store Records (five designs), Door Rate option A, CP vs Internal GP % option A, Photo completion % (optional measure), Who's Moving Now alternate versions and the line-chart versions taken out of the flow (Oct 23), Most Improved v1. Pick what moves into the deck, then delete this section before the meeting.</a:t>
             </a:r>
             <a:endParaRPr lang="en-US" dirty="0"/>
           </a:p>
@@ -2738,7 +2738,7 @@
                 <a:ea typeface="Inter" pitchFamily="34" charset="-122"/>
                 <a:cs typeface="Inter" pitchFamily="34" charset="-120"/>
               </a:rPr>
-              <a:t>Store records   ·   Door rate   ·   CP vs internal   ·   Photo %   ·   Most improved</a:t>
+              <a:t>Store records   ·   Door rate   ·   CP vs internal   ·   Photo %   ·   Who's moving now   ·   Most improved</a:t>
             </a:r>
             <a:endParaRPr lang="en-US" sz="2200" dirty="0"/>
           </a:p>

</xml_diff>

<commit_message>
Moved slides relabelled Customer Pay; agenda and section dividers updated
Co-Authored-By: Claude Opus 5.5 <noreply@anthropic.com>
Claude-Session: https://claude.ai/code/session_01Xa4nFVxuQGXmHARGph9WhS
</commit_message>
<xml_diff>
--- a/day2-deck/decks/Day 2 Opening - Day 1 Style.pptx
+++ b/day2-deck/decks/Day 2 Opening - Day 1 Style.pptx
@@ -3339,7 +3339,7 @@
                 <a:ea typeface="Inter" pitchFamily="34" charset="-122"/>
                 <a:cs typeface="Inter" pitchFamily="34" charset="-120"/>
               </a:rPr>
-              <a:t>ROs, hours per RO, rate and margin.</a:t>
+              <a:t>ROs, hours per RO, pricing and labor mix, rate and margin.</a:t>
             </a:r>
             <a:endParaRPr lang="en-US" sz="1400" dirty="0"/>
           </a:p>
@@ -3653,7 +3653,7 @@
                 <a:ea typeface="Inter" pitchFamily="34" charset="-122"/>
                 <a:cs typeface="Inter" pitchFamily="34" charset="-120"/>
               </a:rPr>
-              <a:t>Pay type and internal, maintenance and repair mix.</a:t>
+              <a:t>Internal labor rate and margin, then tracking and accountability.</a:t>
             </a:r>
             <a:endParaRPr lang="en-US" sz="1400" dirty="0"/>
           </a:p>
@@ -5587,7 +5587,7 @@
                 <a:ea typeface="Inter" pitchFamily="34" charset="-122"/>
                 <a:cs typeface="Inter" pitchFamily="34" charset="-120"/>
               </a:rPr>
-              <a:t>ROs   ·   Hours per RO   ·   ELR   ·   $ per RO   ·   Margin</a:t>
+              <a:t>ROs   ·   Hours per RO   ·   Pricing &amp; mix   ·   ELR   ·   $ per RO   ·   Margin</a:t>
             </a:r>
             <a:endParaRPr lang="en-US" sz="2200" dirty="0"/>
           </a:p>
@@ -6877,7 +6877,7 @@
                 <a:ea typeface="Inter" pitchFamily="34" charset="-122"/>
                 <a:cs typeface="Inter" pitchFamily="34" charset="-120"/>
               </a:rPr>
-              <a:t>Pay type   ·   Internal rate &amp; margin   ·   Work type   ·   Op code descriptions</a:t>
+              <a:t>Internal ELR   ·   Internal labor GP %   ·   Internal parts GP %   ·   Tracking</a:t>
             </a:r>
             <a:endParaRPr lang="en-US" sz="2200" dirty="0"/>
           </a:p>

</xml_diff>

<commit_message>
Section 05 renamed Internal: agenda, divider, tracker and eyebrows
Co-Authored-By: Claude Opus 5.5 <noreply@anthropic.com>
Claude-Session: https://claude.ai/code/session_01Xa4nFVxuQGXmHARGph9WhS
</commit_message>
<xml_diff>
--- a/day2-deck/decks/Day 2 Opening - Day 1 Style.pptx
+++ b/day2-deck/decks/Day 2 Opening - Day 1 Style.pptx
@@ -2388,7 +2388,7 @@
                 <a:ea typeface="Inter" pitchFamily="34" charset="-122"/>
                 <a:cs typeface="Inter" pitchFamily="34" charset="-120"/>
               </a:rPr>
-              <a:t>Labor Mix</a:t>
+              <a:t>Internal</a:t>
             </a:r>
             <a:endParaRPr lang="en-US" sz="1700" dirty="0"/>
           </a:p>
@@ -3614,7 +3614,7 @@
                 <a:ea typeface="Inter" pitchFamily="34" charset="-122"/>
                 <a:cs typeface="Inter" pitchFamily="34" charset="-120"/>
               </a:rPr>
-              <a:t>Labor Mix</a:t>
+              <a:t>Internal</a:t>
             </a:r>
             <a:endParaRPr lang="en-US" sz="1700" dirty="0"/>
           </a:p>
@@ -4592,7 +4592,7 @@
                 <a:ea typeface="Inter" pitchFamily="34" charset="-122"/>
                 <a:cs typeface="Inter" pitchFamily="34" charset="-120"/>
               </a:rPr>
-              <a:t>Labor Mix</a:t>
+              <a:t>Internal</a:t>
             </a:r>
             <a:endParaRPr lang="en-US" sz="1700" dirty="0"/>
           </a:p>
@@ -5237,7 +5237,7 @@
                 <a:ea typeface="Inter" pitchFamily="34" charset="-122"/>
                 <a:cs typeface="Inter" pitchFamily="34" charset="-120"/>
               </a:rPr>
-              <a:t>Labor Mix</a:t>
+              <a:t>Internal</a:t>
             </a:r>
             <a:endParaRPr lang="en-US" sz="1700" dirty="0"/>
           </a:p>
@@ -5882,7 +5882,7 @@
                 <a:ea typeface="Inter" pitchFamily="34" charset="-122"/>
                 <a:cs typeface="Inter" pitchFamily="34" charset="-120"/>
               </a:rPr>
-              <a:t>Labor Mix</a:t>
+              <a:t>Internal</a:t>
             </a:r>
             <a:endParaRPr lang="en-US" sz="1700" dirty="0"/>
           </a:p>
@@ -6527,7 +6527,7 @@
                 <a:ea typeface="Inter" pitchFamily="34" charset="-122"/>
                 <a:cs typeface="Inter" pitchFamily="34" charset="-120"/>
               </a:rPr>
-              <a:t>Labor Mix</a:t>
+              <a:t>Internal</a:t>
             </a:r>
             <a:endParaRPr lang="en-US" sz="1700" dirty="0"/>
           </a:p>
@@ -6838,7 +6838,7 @@
                 <a:ea typeface="Inter" pitchFamily="34" charset="-122"/>
                 <a:cs typeface="Inter" pitchFamily="34" charset="-120"/>
               </a:rPr>
-              <a:t>Labor Mix</a:t>
+              <a:t>Internal</a:t>
             </a:r>
             <a:endParaRPr lang="en-US" sz="7600" dirty="0"/>
           </a:p>
@@ -7172,7 +7172,7 @@
                 <a:ea typeface="Inter" pitchFamily="34" charset="-122"/>
                 <a:cs typeface="Inter" pitchFamily="34" charset="-120"/>
               </a:rPr>
-              <a:t>Labor Mix</a:t>
+              <a:t>Internal</a:t>
             </a:r>
             <a:endParaRPr lang="en-US" sz="1700" dirty="0"/>
           </a:p>
@@ -7817,7 +7817,7 @@
                 <a:ea typeface="Inter" pitchFamily="34" charset="-122"/>
                 <a:cs typeface="Inter" pitchFamily="34" charset="-120"/>
               </a:rPr>
-              <a:t>Labor Mix</a:t>
+              <a:t>Internal</a:t>
             </a:r>
             <a:endParaRPr lang="en-US" sz="1700" dirty="0"/>
           </a:p>
@@ -8462,7 +8462,7 @@
                 <a:ea typeface="Inter" pitchFamily="34" charset="-122"/>
                 <a:cs typeface="Inter" pitchFamily="34" charset="-120"/>
               </a:rPr>
-              <a:t>Labor Mix</a:t>
+              <a:t>Internal</a:t>
             </a:r>
             <a:endParaRPr lang="en-US" sz="1700" dirty="0"/>
           </a:p>

</xml_diff>

<commit_message>
Customer Pay, Opcodes and Internal reshuffle; Goldilocks folded into labor GP explainer; door rate to Open Decisions; work-or-workers slide removed
Co-Authored-By: Claude Opus 5.5 <noreply@anthropic.com>
Claude-Session: https://claude.ai/code/session_01Xa4nFVxuQGXmHARGph9WhS
</commit_message>
<xml_diff>
--- a/day2-deck/decks/Day 2 Opening - Day 1 Style.pptx
+++ b/day2-deck/decks/Day 2 Opening - Day 1 Style.pptx
@@ -3496,7 +3496,7 @@
                 <a:ea typeface="Inter" pitchFamily="34" charset="-122"/>
                 <a:cs typeface="Inter" pitchFamily="34" charset="-120"/>
               </a:rPr>
-              <a:t>MPI and video, then alignment, balance, brake fluid and fuel.</a:t>
+              <a:t>Express service, MPI and video, tracking, then alignment, balance, brake fluid and fuel.</a:t>
             </a:r>
             <a:endParaRPr lang="en-US" sz="1400" dirty="0"/>
           </a:p>
@@ -3653,7 +3653,7 @@
                 <a:ea typeface="Inter" pitchFamily="34" charset="-122"/>
                 <a:cs typeface="Inter" pitchFamily="34" charset="-120"/>
               </a:rPr>
-              <a:t>Internal labor rate and margin, then tracking and accountability.</a:t>
+              <a:t>Internal labor rate and margin.</a:t>
             </a:r>
             <a:endParaRPr lang="en-US" sz="1400" dirty="0"/>
           </a:p>
@@ -6877,7 +6877,7 @@
                 <a:ea typeface="Inter" pitchFamily="34" charset="-122"/>
                 <a:cs typeface="Inter" pitchFamily="34" charset="-120"/>
               </a:rPr>
-              <a:t>Internal ELR   ·   Internal labor GP %   ·   Internal parts GP %   ·   Tracking</a:t>
+              <a:t>Internal ELR   ·   Internal labor GP %   ·   Internal parts GP %</a:t>
             </a:r>
             <a:endParaRPr lang="en-US" sz="2200" dirty="0"/>
           </a:p>

</xml_diff>

<commit_message>
Productivity: headcount leads; ROs per advisor and manager, gross gap and 5% per employee to Open Decisions
Co-Authored-By: Claude Opus 5.5 <noreply@anthropic.com>
Claude-Session: https://claude.ai/code/session_01Xa4nFVxuQGXmHARGph9WhS
</commit_message>
<xml_diff>
--- a/day2-deck/decks/Day 2 Opening - Day 1 Style.pptx
+++ b/day2-deck/decks/Day 2 Opening - Day 1 Style.pptx
@@ -688,7 +688,7 @@
           <a:p>
             <a:r>
               <a:rPr lang="en-US" dirty="0"/>
-              <a:t>For review with Tommy, not for the room. Every slide built but not placed in the deck: alternate versions of slides already in it, and slides not yet decided on. In deck order: Store Records (five designs), Door Rate option A, CP vs Internal GP % option A, Photo completion % (optional measure), Who's Moving Now alternate versions and the line-chart versions taken out of the flow (Oct 23), Most Improved v1. Pick what moves into the deck, then delete this section before the meeting.</a:t>
+              <a:t>For review with Tommy, not for the room. Every slide built but not placed in the deck: alternate versions of slides already in it, and slides not yet decided on. In deck order: Store Records (five designs), Door Rate option A, CP vs Internal GP % option A, Photo completion % (optional measure), Productivity slides taken out of the flow (gross per employee gap, 5% more per employee, ROs per advisor, ROs per manager; Oct 23), Who's Moving Now alternate versions and the line-chart versions taken out of the flow (Oct 23), Most Improved v1. Pick what moves into the deck, then delete this section before the meeting.</a:t>
             </a:r>
             <a:endParaRPr lang="en-US" dirty="0"/>
           </a:p>
@@ -2738,7 +2738,7 @@
                 <a:ea typeface="Inter" pitchFamily="34" charset="-122"/>
                 <a:cs typeface="Inter" pitchFamily="34" charset="-120"/>
               </a:rPr>
-              <a:t>Store records   ·   Door rate   ·   CP vs internal   ·   Photo %   ·   Who's moving now   ·   Most improved</a:t>
+              <a:t>Store records   ·   Door rate   ·   CP vs internal   ·   Photo %   ·   Productivity   ·   Who's moving now   ·   Most improved</a:t>
             </a:r>
             <a:endParaRPr lang="en-US" sz="2200" dirty="0"/>
           </a:p>

</xml_diff>

<commit_message>
Pay Plans: proficiency replaces ROs per advisor; Productivity agenda drops ROs per person; preview updated
Co-Authored-By: Claude Opus 5.5 <noreply@anthropic.com>
Claude-Session: https://claude.ai/code/session_01Xa4nFVxuQGXmHARGph9WhS
</commit_message>
<xml_diff>
--- a/day2-deck/decks/Day 2 Opening - Day 1 Style.pptx
+++ b/day2-deck/decks/Day 2 Opening - Day 1 Style.pptx
@@ -3810,7 +3810,7 @@
                 <a:ea typeface="Inter" pitchFamily="34" charset="-122"/>
                 <a:cs typeface="Inter" pitchFamily="34" charset="-120"/>
               </a:rPr>
-              <a:t>Gross per employee, headcount and technician proficiency.</a:t>
+              <a:t>Headcount, gross per employee and technician proficiency.</a:t>
             </a:r>
             <a:endParaRPr lang="en-US" sz="1400" dirty="0"/>
           </a:p>
@@ -7522,7 +7522,7 @@
                 <a:ea typeface="Inter" pitchFamily="34" charset="-122"/>
                 <a:cs typeface="Inter" pitchFamily="34" charset="-120"/>
               </a:rPr>
-              <a:t>Gross per employee   ·   ROs per person   ·   Headcount   ·   Technician proficiency</a:t>
+              <a:t>Headcount   ·   Gross per employee   ·   Technician proficiency</a:t>
             </a:r>
             <a:endParaRPr lang="en-US" sz="2200" dirty="0"/>
           </a:p>

</xml_diff>

<commit_message>
Agenda: plain-language section descriptions
Co-Authored-By: Claude Opus 5.5 <noreply@anthropic.com>
Claude-Session: https://claude.ai/code/session_01Xa4nFVxuQGXmHARGph9WhS
</commit_message>
<xml_diff>
--- a/day2-deck/decks/Day 2 Opening - Day 1 Style.pptx
+++ b/day2-deck/decks/Day 2 Opening - Day 1 Style.pptx
@@ -3025,7 +3025,7 @@
                 <a:ea typeface="Inter" pitchFamily="34" charset="-122"/>
                 <a:cs typeface="Inter" pitchFamily="34" charset="-120"/>
               </a:rPr>
-              <a:t>Fixed ops, service and parts gross, and the store records.</a:t>
+              <a:t>Fixed ops, service and parts gross performance.</a:t>
             </a:r>
             <a:endParaRPr lang="en-US" sz="1400" dirty="0"/>
           </a:p>
@@ -3182,7 +3182,7 @@
                 <a:ea typeface="Inter" pitchFamily="34" charset="-122"/>
                 <a:cs typeface="Inter" pitchFamily="34" charset="-120"/>
               </a:rPr>
-              <a:t>Absorption and net to gross.</a:t>
+              <a:t>What we keep, and how much of the store we cover.</a:t>
             </a:r>
             <a:endParaRPr lang="en-US" sz="1400" dirty="0"/>
           </a:p>
@@ -3339,7 +3339,7 @@
                 <a:ea typeface="Inter" pitchFamily="34" charset="-122"/>
                 <a:cs typeface="Inter" pitchFamily="34" charset="-120"/>
               </a:rPr>
-              <a:t>ROs, hours per RO, pricing and labor mix, rate and margin.</a:t>
+              <a:t>Car count, sales per visit, pricing and margin.</a:t>
             </a:r>
             <a:endParaRPr lang="en-US" sz="1400" dirty="0"/>
           </a:p>
@@ -3496,7 +3496,7 @@
                 <a:ea typeface="Inter" pitchFamily="34" charset="-122"/>
                 <a:cs typeface="Inter" pitchFamily="34" charset="-120"/>
               </a:rPr>
-              <a:t>Express service, MPI and video, tracking, then alignment, balance, brake fluid and fuel.</a:t>
+              <a:t>Inspections and key services against benchmark.</a:t>
             </a:r>
             <a:endParaRPr lang="en-US" sz="1400" dirty="0"/>
           </a:p>
@@ -3653,7 +3653,7 @@
                 <a:ea typeface="Inter" pitchFamily="34" charset="-122"/>
                 <a:cs typeface="Inter" pitchFamily="34" charset="-120"/>
               </a:rPr>
-              <a:t>Internal labor rate and margin.</a:t>
+              <a:t>Internal labor rate and margins.</a:t>
             </a:r>
             <a:endParaRPr lang="en-US" sz="1400" dirty="0"/>
           </a:p>
@@ -3810,7 +3810,7 @@
                 <a:ea typeface="Inter" pitchFamily="34" charset="-122"/>
                 <a:cs typeface="Inter" pitchFamily="34" charset="-120"/>
               </a:rPr>
-              <a:t>Headcount, gross per employee and technician proficiency.</a:t>
+              <a:t>Staffing, output and technician proficiency.</a:t>
             </a:r>
             <a:endParaRPr lang="en-US" sz="1400" dirty="0"/>
           </a:p>
@@ -3967,7 +3967,7 @@
                 <a:ea typeface="Inter" pitchFamily="34" charset="-122"/>
                 <a:cs typeface="Inter" pitchFamily="34" charset="-120"/>
               </a:rPr>
-              <a:t>Rate increases, warranty rate and parts margin, audits and compliance.</a:t>
+              <a:t>Warranty rates, margins and compliance.</a:t>
             </a:r>
             <a:endParaRPr lang="en-US" sz="1400" dirty="0"/>
           </a:p>
@@ -4124,7 +4124,7 @@
                 <a:ea typeface="Inter" pitchFamily="34" charset="-122"/>
                 <a:cs typeface="Inter" pitchFamily="34" charset="-120"/>
               </a:rPr>
-              <a:t>What changed, where the money is, and commitments.</a:t>
+              <a:t>What changed, where the money is, and what we commit to.</a:t>
             </a:r>
             <a:endParaRPr lang="en-US" sz="1400" dirty="0"/>
           </a:p>

</xml_diff>

<commit_message>
Day 2 deck: GMC Prescott body shop back in absorption; section dividers approved
Co-Authored-By: Claude Opus 5.5 <noreply@anthropic.com>
Claude-Session: https://claude.ai/code/session_01Xa4nFVxuQGXmHARGph9WhS
</commit_message>
<xml_diff>
--- a/day2-deck/decks/Day 2 Opening - Day 1 Style.pptx
+++ b/day2-deck/decks/Day 2 Opening - Day 1 Style.pptx
@@ -2093,7 +2093,7 @@
                 <a:ea typeface="Inter" pitchFamily="34" charset="-122"/>
                 <a:cs typeface="Inter" pitchFamily="34" charset="-120"/>
               </a:rPr>
-              <a:t>Most improved   ·   Where the money is   ·   Before you leave</a:t>
+              <a:t>Most improved   ·   Where the money is   ·   Store prescriptions</a:t>
             </a:r>
             <a:endParaRPr lang="en-US" sz="2200" dirty="0"/>
           </a:p>
@@ -3967,7 +3967,7 @@
                 <a:ea typeface="Inter" pitchFamily="34" charset="-122"/>
                 <a:cs typeface="Inter" pitchFamily="34" charset="-120"/>
               </a:rPr>
-              <a:t>Warranty rates, margins and compliance.</a:t>
+              <a:t>Rates, margins and compliance: protecting the money.</a:t>
             </a:r>
             <a:endParaRPr lang="en-US" sz="1400" dirty="0"/>
           </a:p>
@@ -4124,7 +4124,7 @@
                 <a:ea typeface="Inter" pitchFamily="34" charset="-122"/>
                 <a:cs typeface="Inter" pitchFamily="34" charset="-120"/>
               </a:rPr>
-              <a:t>What changed, where the money is, and what we commit to.</a:t>
+              <a:t>What changed, where the money is, and each store's prescription.</a:t>
             </a:r>
             <a:endParaRPr lang="en-US" sz="1400" dirty="0"/>
           </a:p>
@@ -8167,7 +8167,7 @@
                 <a:ea typeface="Inter" pitchFamily="34" charset="-122"/>
                 <a:cs typeface="Inter" pitchFamily="34" charset="-120"/>
               </a:rPr>
-              <a:t>Rate increases   ·   Warranty ELR   ·   Parts margin   ·   Warranty audits</a:t>
+              <a:t>Rates rising   ·   Warranty gross profit   ·   Claim process: protect the money</a:t>
             </a:r>
             <a:endParaRPr lang="en-US" sz="2200" dirty="0"/>
           </a:p>

</xml_diff>

<commit_message>
Agenda wording: Profitability and Close
Co-Authored-By: Claude Opus 5.5 <noreply@anthropic.com>
Claude-Session: https://claude.ai/code/session_01Xa4nFVxuQGXmHARGph9WhS
</commit_message>
<xml_diff>
--- a/day2-deck/decks/Day 2 Opening - Day 1 Style.pptx
+++ b/day2-deck/decks/Day 2 Opening - Day 1 Style.pptx
@@ -3182,7 +3182,7 @@
                 <a:ea typeface="Inter" pitchFamily="34" charset="-122"/>
                 <a:cs typeface="Inter" pitchFamily="34" charset="-120"/>
               </a:rPr>
-              <a:t>What we keep, and how much of the store we cover.</a:t>
+              <a:t>What we keep, and how much of the store's expenses fixed ops covers.</a:t>
             </a:r>
             <a:endParaRPr lang="en-US" sz="1400" dirty="0"/>
           </a:p>
@@ -4124,7 +4124,7 @@
                 <a:ea typeface="Inter" pitchFamily="34" charset="-122"/>
                 <a:cs typeface="Inter" pitchFamily="34" charset="-120"/>
               </a:rPr>
-              <a:t>What changed, where the money is, and each store's prescription.</a:t>
+              <a:t>What changed, where the money is, and prescriptions.</a:t>
             </a:r>
             <a:endParaRPr lang="en-US" sz="1400" dirty="0"/>
           </a:p>

</xml_diff>

<commit_message>
Agenda wording: Profitability and Warranty (Noah)
Co-Authored-By: Claude Opus 5.5 <noreply@anthropic.com>
Claude-Session: https://claude.ai/code/session_01Xa4nFVxuQGXmHARGph9WhS
</commit_message>
<xml_diff>
--- a/day2-deck/decks/Day 2 Opening - Day 1 Style.pptx
+++ b/day2-deck/decks/Day 2 Opening - Day 1 Style.pptx
@@ -3182,7 +3182,7 @@
                 <a:ea typeface="Inter" pitchFamily="34" charset="-122"/>
                 <a:cs typeface="Inter" pitchFamily="34" charset="-120"/>
               </a:rPr>
-              <a:t>What we keep, and how much of the store's expenses fixed ops covers.</a:t>
+              <a:t>What we keep, and how much of the store expenses we cover.</a:t>
             </a:r>
             <a:endParaRPr lang="en-US" sz="1400" dirty="0"/>
           </a:p>
@@ -3967,7 +3967,7 @@
                 <a:ea typeface="Inter" pitchFamily="34" charset="-122"/>
                 <a:cs typeface="Inter" pitchFamily="34" charset="-120"/>
               </a:rPr>
-              <a:t>Rates, margins and compliance: protecting the money.</a:t>
+              <a:t>Rates, margins, compliance, and protecting the money.</a:t>
             </a:r>
             <a:endParaRPr lang="en-US" sz="1400" dirty="0"/>
           </a:p>

</xml_diff>